<commit_message>
update Ch2 Number Systems for Digital Forensics presentation
</commit_message>
<xml_diff>
--- a/PPTs/Ch2_Number_Systems_for_Digital_Forensics.pptx
+++ b/PPTs/Ch2_Number_Systems_for_Digital_Forensics.pptx
@@ -5,7 +5,7 @@
     <p:sldMasterId id="2147483648" r:id="rId1"/>
   </p:sldMasterIdLst>
   <p:notesMasterIdLst>
-    <p:notesMasterId r:id="rId42"/>
+    <p:notesMasterId r:id="rId43"/>
   </p:notesMasterIdLst>
   <p:sldIdLst>
     <p:sldId id="256" r:id="rId2"/>
@@ -48,6 +48,7 @@
     <p:sldId id="269" r:id="rId39"/>
     <p:sldId id="270" r:id="rId40"/>
     <p:sldId id="273" r:id="rId41"/>
+    <p:sldId id="297" r:id="rId42"/>
   </p:sldIdLst>
   <p:sldSz cx="12192000" cy="6858000"/>
   <p:notesSz cx="6858000" cy="9144000"/>
@@ -1347,7 +1348,7 @@
           <a:p>
             <a:fld id="{B9658D5F-65FB-4E17-9D5B-8CF1DE5A98DF}" type="datetimeFigureOut">
               <a:rPr lang="en-US" smtClean="0"/>
-              <a:t>1/28/2026</a:t>
+              <a:t>9/13/2026</a:t>
             </a:fld>
             <a:endParaRPr lang="en-US"/>
           </a:p>
@@ -4330,7 +4331,7 @@
           <a:p>
             <a:fld id="{4263717A-E3C1-4BED-ABE0-B7069385E023}" type="datetimeFigureOut">
               <a:rPr lang="en-US" smtClean="0"/>
-              <a:t>1/28/2026</a:t>
+              <a:t>9/13/2026</a:t>
             </a:fld>
             <a:endParaRPr lang="en-US"/>
           </a:p>
@@ -4503,7 +4504,7 @@
           <a:p>
             <a:fld id="{4263717A-E3C1-4BED-ABE0-B7069385E023}" type="datetimeFigureOut">
               <a:rPr lang="en-US" smtClean="0"/>
-              <a:t>1/28/2026</a:t>
+              <a:t>9/13/2026</a:t>
             </a:fld>
             <a:endParaRPr lang="en-US"/>
           </a:p>
@@ -4681,7 +4682,7 @@
           <a:p>
             <a:fld id="{4263717A-E3C1-4BED-ABE0-B7069385E023}" type="datetimeFigureOut">
               <a:rPr lang="en-US" smtClean="0"/>
-              <a:t>1/28/2026</a:t>
+              <a:t>9/13/2026</a:t>
             </a:fld>
             <a:endParaRPr lang="en-US"/>
           </a:p>
@@ -4849,7 +4850,7 @@
           <a:p>
             <a:fld id="{4263717A-E3C1-4BED-ABE0-B7069385E023}" type="datetimeFigureOut">
               <a:rPr lang="en-US" smtClean="0"/>
-              <a:t>1/28/2026</a:t>
+              <a:t>9/13/2026</a:t>
             </a:fld>
             <a:endParaRPr lang="en-US"/>
           </a:p>
@@ -5094,7 +5095,7 @@
           <a:p>
             <a:fld id="{4263717A-E3C1-4BED-ABE0-B7069385E023}" type="datetimeFigureOut">
               <a:rPr lang="en-US" smtClean="0"/>
-              <a:t>1/28/2026</a:t>
+              <a:t>9/13/2026</a:t>
             </a:fld>
             <a:endParaRPr lang="en-US"/>
           </a:p>
@@ -5323,7 +5324,7 @@
           <a:p>
             <a:fld id="{4263717A-E3C1-4BED-ABE0-B7069385E023}" type="datetimeFigureOut">
               <a:rPr lang="en-US" smtClean="0"/>
-              <a:t>1/28/2026</a:t>
+              <a:t>9/13/2026</a:t>
             </a:fld>
             <a:endParaRPr lang="en-US"/>
           </a:p>
@@ -5687,7 +5688,7 @@
           <a:p>
             <a:fld id="{4263717A-E3C1-4BED-ABE0-B7069385E023}" type="datetimeFigureOut">
               <a:rPr lang="en-US" smtClean="0"/>
-              <a:t>1/28/2026</a:t>
+              <a:t>9/13/2026</a:t>
             </a:fld>
             <a:endParaRPr lang="en-US"/>
           </a:p>
@@ -5804,7 +5805,7 @@
           <a:p>
             <a:fld id="{4263717A-E3C1-4BED-ABE0-B7069385E023}" type="datetimeFigureOut">
               <a:rPr lang="en-US" smtClean="0"/>
-              <a:t>1/28/2026</a:t>
+              <a:t>9/13/2026</a:t>
             </a:fld>
             <a:endParaRPr lang="en-US"/>
           </a:p>
@@ -5899,7 +5900,7 @@
           <a:p>
             <a:fld id="{4263717A-E3C1-4BED-ABE0-B7069385E023}" type="datetimeFigureOut">
               <a:rPr lang="en-US" smtClean="0"/>
-              <a:t>1/28/2026</a:t>
+              <a:t>9/13/2026</a:t>
             </a:fld>
             <a:endParaRPr lang="en-US"/>
           </a:p>
@@ -6174,7 +6175,7 @@
           <a:p>
             <a:fld id="{4263717A-E3C1-4BED-ABE0-B7069385E023}" type="datetimeFigureOut">
               <a:rPr lang="en-US" smtClean="0"/>
-              <a:t>1/28/2026</a:t>
+              <a:t>9/13/2026</a:t>
             </a:fld>
             <a:endParaRPr lang="en-US"/>
           </a:p>
@@ -6426,7 +6427,7 @@
           <a:p>
             <a:fld id="{4263717A-E3C1-4BED-ABE0-B7069385E023}" type="datetimeFigureOut">
               <a:rPr lang="en-US" smtClean="0"/>
-              <a:t>1/28/2026</a:t>
+              <a:t>9/13/2026</a:t>
             </a:fld>
             <a:endParaRPr lang="en-US"/>
           </a:p>
@@ -6637,7 +6638,7 @@
           <a:p>
             <a:fld id="{4263717A-E3C1-4BED-ABE0-B7069385E023}" type="datetimeFigureOut">
               <a:rPr lang="en-US" smtClean="0"/>
-              <a:t>1/28/2026</a:t>
+              <a:t>9/13/2026</a:t>
             </a:fld>
             <a:endParaRPr lang="en-US"/>
           </a:p>
@@ -7216,29 +7217,19 @@
             <p:ph type="ctrTitle"/>
           </p:nvPr>
         </p:nvSpPr>
-        <p:spPr>
-          <a:xfrm>
-            <a:off x="1524000" y="1122363"/>
-            <a:ext cx="9144000" cy="2387600"/>
-          </a:xfrm>
-        </p:spPr>
+        <p:spPr/>
         <p:txBody>
           <a:bodyPr>
             <a:normAutofit/>
           </a:bodyPr>
           <a:lstStyle/>
           <a:p>
-            <a:r>
-              <a:rPr lang="en-US" dirty="0"/>
-              <a:t>Understand Number Systems and</a:t>
-            </a:r>
-            <a:r>
-              <a:rPr lang="zh-CN" altLang="en-US" dirty="0"/>
-              <a:t> </a:t>
-            </a:r>
-            <a:r>
-              <a:rPr lang="en-US" altLang="zh-CN" dirty="0"/>
-              <a:t>Timestamps</a:t>
+            <a:pPr>
+              <a:defRPr sz="4400" b="0"/>
+            </a:pPr>
+            <a:r>
+              <a:rPr dirty="0"/>
+              <a:t>Number Systems, Text Encoding, and Timestamps</a:t>
             </a:r>
             <a:endParaRPr lang="en-US" dirty="0"/>
           </a:p>
@@ -7246,10 +7237,10 @@
       </p:sp>
       <p:sp>
         <p:nvSpPr>
-          <p:cNvPr id="7" name="Subtitle 6">
+          <p:cNvPr id="3" name="Subtitle 2">
             <a:extLst>
               <a:ext uri="{FF2B5EF4-FFF2-40B4-BE49-F238E27FC236}">
-                <a16:creationId xmlns:a16="http://schemas.microsoft.com/office/drawing/2014/main" id="{F2871076-CFC8-4CD5-BF65-ECB4ACAEF8D8}"/>
+                <a16:creationId xmlns:a16="http://schemas.microsoft.com/office/drawing/2014/main" id="{324C0768-47C5-A7E4-3442-1A8B9178C9DA}"/>
               </a:ext>
             </a:extLst>
           </p:cNvPr>
@@ -7265,16 +7256,7 @@
           <a:bodyPr/>
           <a:lstStyle/>
           <a:p>
-            <a:r>
-              <a:rPr lang="en-US" dirty="0"/>
-              <a:t>Frank Xu</a:t>
-            </a:r>
-          </a:p>
-          <a:p>
-            <a:r>
-              <a:rPr lang="en-US" dirty="0"/>
-              <a:t>wxu@ubalt.edu</a:t>
-            </a:r>
+            <a:endParaRPr lang="en-US"/>
           </a:p>
         </p:txBody>
       </p:sp>
@@ -7329,9 +7311,12 @@
           <a:bodyPr/>
           <a:lstStyle/>
           <a:p>
-            <a:r>
-              <a:rPr lang="en-US" dirty="0"/>
-              <a:t>Binary to Decimal (Python code)</a:t>
+            <a:pPr algn="l">
+              <a:defRPr sz="3600" b="0"/>
+            </a:pPr>
+            <a:r>
+              <a:rPr dirty="0"/>
+              <a:t>Binary to Decimal in Python</a:t>
             </a:r>
           </a:p>
         </p:txBody>
@@ -7448,7 +7433,7 @@
         <p:spPr>
           <a:xfrm>
             <a:off x="838200" y="3994787"/>
-            <a:ext cx="2420343" cy="369332"/>
+            <a:ext cx="3566160" cy="369332"/>
           </a:xfrm>
           <a:prstGeom prst="rect">
             <a:avLst/>
@@ -7463,9 +7448,11 @@
           </a:bodyPr>
           <a:lstStyle/>
           <a:p>
-            <a:r>
-              <a:rPr lang="en-US" dirty="0"/>
-              <a:t>I use Python version 3.9</a:t>
+            <a:pPr>
+              <a:defRPr sz="1800"/>
+            </a:pPr>
+            <a:r>
+              <a:t>Use Python 3 for this course</a:t>
             </a:r>
           </a:p>
         </p:txBody>
@@ -7503,15 +7490,19 @@
           </a:bodyPr>
           <a:lstStyle/>
           <a:p>
-            <a:r>
-              <a:rPr lang="en-US"/>
-              <a:t># hex to int</a:t>
-            </a:r>
-          </a:p>
-          <a:p>
-            <a:r>
-              <a:rPr lang="en-US" dirty="0"/>
-              <a:t>int ("800", 16)</a:t>
+            <a:pPr>
+              <a:defRPr sz="1800"/>
+            </a:pPr>
+            <a:r>
+              <a:rPr dirty="0"/>
+              <a:t># binary to int</a:t>
+            </a:r>
+            <a:br>
+              <a:rPr dirty="0"/>
+            </a:br>
+            <a:r>
+              <a:rPr dirty="0"/>
+              <a:t>int("101010", 2)</a:t>
             </a:r>
           </a:p>
         </p:txBody>
@@ -7567,8 +7558,10 @@
           <a:bodyPr/>
           <a:lstStyle/>
           <a:p>
-            <a:r>
-              <a:rPr lang="en-US" dirty="0"/>
+            <a:pPr algn="l">
+              <a:defRPr sz="3600" b="0"/>
+            </a:pPr>
+            <a:r>
               <a:t>Hexadecimal to Decimal</a:t>
             </a:r>
           </a:p>
@@ -7597,56 +7590,57 @@
           </a:xfrm>
         </p:spPr>
         <p:txBody>
-          <a:bodyPr/>
+          <a:bodyPr>
+            <a:normAutofit lnSpcReduction="10000"/>
+          </a:bodyPr>
           <a:lstStyle/>
           <a:p>
-            <a:r>
-              <a:rPr lang="en-US" altLang="en-US" dirty="0"/>
-              <a:t>Multiply each bit by </a:t>
-            </a:r>
-            <a:r>
-              <a:rPr lang="en-US" altLang="en-US" dirty="0">
-                <a:solidFill>
-                  <a:srgbClr val="C00000"/>
-                </a:solidFill>
-              </a:rPr>
-              <a:t>16</a:t>
-            </a:r>
-            <a:r>
-              <a:rPr lang="en-US" altLang="en-US" sz="3300" i="1" baseline="30000" dirty="0">
-                <a:solidFill>
-                  <a:srgbClr val="C00000"/>
-                </a:solidFill>
-              </a:rPr>
-              <a:t>n</a:t>
-            </a:r>
-            <a:r>
-              <a:rPr lang="en-US" altLang="en-US" dirty="0"/>
-              <a:t>, where </a:t>
-            </a:r>
-            <a:r>
-              <a:rPr lang="en-US" altLang="en-US" i="1" dirty="0"/>
-              <a:t>n</a:t>
-            </a:r>
-            <a:r>
-              <a:rPr lang="en-US" altLang="en-US" dirty="0"/>
-              <a:t> is the “weight” of the bit</a:t>
+            <a:pPr>
+              <a:spcAft>
+                <a:spcPts val="600"/>
+              </a:spcAft>
+              <a:defRPr sz="2400"/>
+            </a:pPr>
+            <a:r>
+              <a:rPr dirty="0"/>
+              <a:t>Multiply each hexadecimal digit by 16ⁿ</a:t>
             </a:r>
           </a:p>
           <a:p>
-            <a:r>
-              <a:rPr lang="en-US" altLang="en-US" dirty="0"/>
-              <a:t>The weight is the position of the bit, starting from 0 on the right</a:t>
+            <a:pPr>
+              <a:spcAft>
+                <a:spcPts val="600"/>
+              </a:spcAft>
+              <a:defRPr sz="2400"/>
+            </a:pPr>
+            <a:r>
+              <a:rPr dirty="0"/>
+              <a:t>Count positions from the right, starting at 0</a:t>
             </a:r>
           </a:p>
           <a:p>
-            <a:r>
-              <a:rPr lang="en-US" altLang="en-US" dirty="0"/>
-              <a:t>Add the results</a:t>
+            <a:pPr>
+              <a:spcAft>
+                <a:spcPts val="600"/>
+              </a:spcAft>
+              <a:defRPr sz="2400"/>
+            </a:pPr>
+            <a:r>
+              <a:rPr dirty="0"/>
+              <a:t>A–F represent decimal values 10–15</a:t>
             </a:r>
           </a:p>
           <a:p>
-            <a:endParaRPr lang="en-US" dirty="0"/>
+            <a:pPr>
+              <a:spcAft>
+                <a:spcPts val="600"/>
+              </a:spcAft>
+              <a:defRPr sz="2400"/>
+            </a:pPr>
+            <a:r>
+              <a:rPr dirty="0"/>
+              <a:t>Add the products to get the decimal value</a:t>
+            </a:r>
           </a:p>
         </p:txBody>
       </p:sp>
@@ -8361,9 +8355,11 @@
           <a:bodyPr/>
           <a:lstStyle/>
           <a:p>
-            <a:r>
-              <a:rPr lang="en-US" dirty="0"/>
-              <a:t>Decimal to Binary</a:t>
+            <a:pPr algn="l">
+              <a:defRPr sz="3600" b="0"/>
+            </a:pPr>
+            <a:r>
+              <a:t>Decimal to Binary: Repeated Division</a:t>
             </a:r>
           </a:p>
         </p:txBody>
@@ -8394,43 +8390,48 @@
           <a:bodyPr/>
           <a:lstStyle/>
           <a:p>
-            <a:r>
-              <a:rPr lang="en-US" altLang="en-US" dirty="0"/>
-              <a:t>Divide by </a:t>
-            </a:r>
-            <a:r>
-              <a:rPr lang="en-US" altLang="en-US" dirty="0">
-                <a:solidFill>
-                  <a:srgbClr val="FF0000"/>
-                </a:solidFill>
-              </a:rPr>
-              <a:t>2</a:t>
-            </a:r>
-            <a:r>
-              <a:rPr lang="en-US" altLang="en-US" dirty="0"/>
-              <a:t>, keep track of the remainder</a:t>
+            <a:pPr>
+              <a:spcAft>
+                <a:spcPts val="600"/>
+              </a:spcAft>
+              <a:defRPr sz="2400"/>
+            </a:pPr>
+            <a:r>
+              <a:t>Divide by 2 and record each remainder</a:t>
             </a:r>
           </a:p>
           <a:p>
-            <a:r>
-              <a:rPr lang="en-US" altLang="en-US" dirty="0"/>
-              <a:t>First remainder is bit 0 (LSB, least-significant bit)</a:t>
+            <a:pPr>
+              <a:spcAft>
+                <a:spcPts val="600"/>
+              </a:spcAft>
+              <a:defRPr sz="2400"/>
+            </a:pPr>
+            <a:r>
+              <a:t>The first remainder is the least-significant bit</a:t>
             </a:r>
           </a:p>
           <a:p>
-            <a:r>
-              <a:rPr lang="en-US" altLang="en-US" dirty="0"/>
-              <a:t>Second remainder is bit 1</a:t>
+            <a:pPr>
+              <a:spcAft>
+                <a:spcPts val="600"/>
+              </a:spcAft>
+              <a:defRPr sz="2400"/>
+            </a:pPr>
+            <a:r>
+              <a:t>Continue until the quotient is 0</a:t>
             </a:r>
           </a:p>
           <a:p>
-            <a:r>
-              <a:rPr lang="en-US" altLang="en-US" dirty="0"/>
-              <a:t>Etc.</a:t>
-            </a:r>
-          </a:p>
-          <a:p>
-            <a:endParaRPr lang="en-US" dirty="0"/>
+            <a:pPr>
+              <a:spcAft>
+                <a:spcPts val="600"/>
+              </a:spcAft>
+              <a:defRPr sz="2400"/>
+            </a:pPr>
+            <a:r>
+              <a:t>Read remainders from bottom to top</a:t>
+            </a:r>
           </a:p>
         </p:txBody>
       </p:sp>
@@ -10519,7 +10520,7 @@
                 <a:effectLst/>
                 <a:latin typeface="urw-din"/>
               </a:rPr>
-              <a:t>basic calculator </a:t>
+              <a:t>bc calculator </a:t>
             </a:r>
             <a:endParaRPr lang="en-US" dirty="0"/>
           </a:p>
@@ -10997,8 +10998,10 @@
           <a:bodyPr/>
           <a:lstStyle/>
           <a:p>
-            <a:r>
-              <a:rPr lang="en-US" dirty="0"/>
+            <a:pPr algn="l">
+              <a:defRPr sz="3600" b="0"/>
+            </a:pPr>
+            <a:r>
               <a:t>Decimal to Hexadecimal</a:t>
             </a:r>
           </a:p>
@@ -11027,30 +11030,42 @@
           </a:xfrm>
         </p:spPr>
         <p:txBody>
-          <a:bodyPr/>
+          <a:bodyPr>
+            <a:normAutofit fontScale="92500" lnSpcReduction="10000"/>
+          </a:bodyPr>
           <a:lstStyle/>
           <a:p>
-            <a:r>
-              <a:rPr lang="en-GB" dirty="0"/>
-              <a:t>Divide by </a:t>
-            </a:r>
-            <a:r>
-              <a:rPr lang="en-GB" dirty="0">
-                <a:solidFill>
-                  <a:srgbClr val="C00000"/>
-                </a:solidFill>
-              </a:rPr>
-              <a:t>16</a:t>
+            <a:pPr>
+              <a:spcAft>
+                <a:spcPts val="600"/>
+              </a:spcAft>
+              <a:defRPr sz="2400"/>
+            </a:pPr>
+            <a:r>
+              <a:t>Divide by 16 and record the remainder</a:t>
             </a:r>
           </a:p>
           <a:p>
-            <a:r>
-              <a:rPr lang="en-GB" dirty="0"/>
-              <a:t>Keep track of the remainder</a:t>
+            <a:pPr>
+              <a:spcAft>
+                <a:spcPts val="600"/>
+              </a:spcAft>
+              <a:defRPr sz="2400"/>
+            </a:pPr>
+            <a:r>
+              <a:t>Remainders 10–15 become A–F</a:t>
             </a:r>
           </a:p>
           <a:p>
-            <a:endParaRPr lang="en-US" dirty="0"/>
+            <a:pPr>
+              <a:spcAft>
+                <a:spcPts val="600"/>
+              </a:spcAft>
+              <a:defRPr sz="2400"/>
+            </a:pPr>
+            <a:r>
+              <a:t>Read remainders from bottom to top</a:t>
+            </a:r>
           </a:p>
         </p:txBody>
       </p:sp>
@@ -12696,9 +12711,11 @@
           <a:bodyPr/>
           <a:lstStyle/>
           <a:p>
-            <a:r>
-              <a:rPr lang="en-US" dirty="0"/>
-              <a:t>Decimal to Binary and Hex (Python code)</a:t>
+            <a:pPr algn="l">
+              <a:defRPr sz="3600" b="0"/>
+            </a:pPr>
+            <a:r>
+              <a:t>Decimal to Binary and Hex in Python</a:t>
             </a:r>
           </a:p>
         </p:txBody>
@@ -12832,7 +12849,7 @@
           <a:p>
             <a:r>
               <a:rPr lang="en-US" dirty="0"/>
-              <a:t>Decimal to Hex</a:t>
+              <a:t>Decimal to Hexadecimal</a:t>
             </a:r>
           </a:p>
         </p:txBody>
@@ -12888,8 +12905,10 @@
           <a:bodyPr/>
           <a:lstStyle/>
           <a:p>
-            <a:r>
-              <a:rPr lang="en-US" dirty="0"/>
+            <a:pPr algn="l">
+              <a:defRPr sz="3600" b="0"/>
+            </a:pPr>
+            <a:r>
               <a:t>Binary to Hexadecimal</a:t>
             </a:r>
           </a:p>
@@ -12921,39 +12940,48 @@
           <a:bodyPr/>
           <a:lstStyle/>
           <a:p>
-            <a:r>
-              <a:rPr lang="en-GB" dirty="0"/>
-              <a:t>Group bits in </a:t>
-            </a:r>
-            <a:r>
-              <a:rPr lang="en-GB" dirty="0">
-                <a:solidFill>
-                  <a:srgbClr val="FF0000"/>
-                </a:solidFill>
-              </a:rPr>
-              <a:t>fours</a:t>
-            </a:r>
-            <a:r>
-              <a:rPr lang="en-GB" dirty="0"/>
-              <a:t>, starting on </a:t>
-            </a:r>
-            <a:r>
-              <a:rPr lang="en-GB" dirty="0">
-                <a:solidFill>
-                  <a:srgbClr val="FF0000"/>
-                </a:solidFill>
-              </a:rPr>
-              <a:t>right</a:t>
+            <a:pPr>
+              <a:spcAft>
+                <a:spcPts val="600"/>
+              </a:spcAft>
+              <a:defRPr sz="2400"/>
+            </a:pPr>
+            <a:r>
+              <a:t>Group bits into nibbles: 4 bits per group</a:t>
             </a:r>
           </a:p>
           <a:p>
-            <a:r>
-              <a:rPr lang="en-GB" dirty="0"/>
-              <a:t>Convert to hexadecimal digits</a:t>
+            <a:pPr>
+              <a:spcAft>
+                <a:spcPts val="600"/>
+              </a:spcAft>
+              <a:defRPr sz="2400"/>
+            </a:pPr>
+            <a:r>
+              <a:t>Start grouping from the right</a:t>
             </a:r>
           </a:p>
           <a:p>
-            <a:endParaRPr lang="en-US" dirty="0"/>
+            <a:pPr>
+              <a:spcAft>
+                <a:spcPts val="600"/>
+              </a:spcAft>
+              <a:defRPr sz="2400"/>
+            </a:pPr>
+            <a:r>
+              <a:t>Add leading zeros only if needed</a:t>
+            </a:r>
+          </a:p>
+          <a:p>
+            <a:pPr>
+              <a:spcAft>
+                <a:spcPts val="600"/>
+              </a:spcAft>
+              <a:defRPr sz="2400"/>
+            </a:pPr>
+            <a:r>
+              <a:t>Convert each nibble to one hexadecimal digit</a:t>
+            </a:r>
           </a:p>
         </p:txBody>
       </p:sp>
@@ -14214,9 +14242,11 @@
           <a:bodyPr/>
           <a:lstStyle/>
           <a:p>
-            <a:r>
-              <a:rPr lang="en-US" dirty="0"/>
-              <a:t>American Standard Code for Information Interchange</a:t>
+            <a:pPr algn="l">
+              <a:defRPr sz="4400" b="0"/>
+            </a:pPr>
+            <a:r>
+              <a:t>ASCII: American Standard Code for Information Interchange</a:t>
             </a:r>
           </a:p>
         </p:txBody>
@@ -14242,9 +14272,15 @@
           <a:bodyPr/>
           <a:lstStyle/>
           <a:p>
-            <a:r>
-              <a:rPr lang="en-US" dirty="0"/>
-              <a:t>ASCII Code</a:t>
+            <a:pPr algn="l">
+              <a:defRPr sz="2000">
+                <a:solidFill>
+                  <a:srgbClr val="787878"/>
+                </a:solidFill>
+              </a:defRPr>
+            </a:pPr>
+            <a:r>
+              <a:t>Text encoding begins with bytes.</a:t>
             </a:r>
           </a:p>
         </p:txBody>
@@ -14300,9 +14336,11 @@
           <a:bodyPr/>
           <a:lstStyle/>
           <a:p>
-            <a:r>
-              <a:rPr lang="en-US" dirty="0"/>
-              <a:t>Bit, Byte</a:t>
+            <a:pPr algn="l">
+              <a:defRPr sz="3600" b="0"/>
+            </a:pPr>
+            <a:r>
+              <a:t>Bits and Bytes</a:t>
             </a:r>
           </a:p>
         </p:txBody>
@@ -14333,75 +14371,48 @@
           <a:bodyPr/>
           <a:lstStyle/>
           <a:p>
-            <a:r>
-              <a:rPr lang="en-GB" dirty="0"/>
-              <a:t>A ‘bit’ (from </a:t>
-            </a:r>
-            <a:r>
-              <a:rPr lang="en-GB" dirty="0">
-                <a:solidFill>
-                  <a:srgbClr val="FF0000"/>
-                </a:solidFill>
-              </a:rPr>
-              <a:t>B</a:t>
-            </a:r>
-            <a:r>
-              <a:rPr lang="en-GB" dirty="0"/>
-              <a:t>inary + </a:t>
-            </a:r>
-            <a:r>
-              <a:rPr lang="en-GB" dirty="0" err="1"/>
-              <a:t>dig</a:t>
-            </a:r>
-            <a:r>
-              <a:rPr lang="en-GB" dirty="0" err="1">
-                <a:solidFill>
-                  <a:srgbClr val="FF0000"/>
-                </a:solidFill>
-              </a:rPr>
-              <a:t>IT</a:t>
-            </a:r>
-            <a:r>
-              <a:rPr lang="en-GB" dirty="0"/>
-              <a:t>) </a:t>
+            <a:pPr>
+              <a:spcAft>
+                <a:spcPts val="600"/>
+              </a:spcAft>
+              <a:defRPr sz="2300"/>
+            </a:pPr>
+            <a:r>
+              <a:t>A bit is a single binary value: 0 or 1</a:t>
             </a:r>
           </a:p>
           <a:p>
-            <a:pPr lvl="1"/>
-            <a:r>
-              <a:rPr lang="en-GB" dirty="0"/>
-              <a:t>is the smallest unit of memory, </a:t>
+            <a:pPr>
+              <a:spcAft>
+                <a:spcPts val="600"/>
+              </a:spcAft>
+              <a:defRPr sz="2300"/>
+            </a:pPr>
+            <a:r>
+              <a:t>A byte is a collection of 8 bits</a:t>
             </a:r>
           </a:p>
           <a:p>
-            <a:pPr lvl="1"/>
-            <a:r>
-              <a:rPr lang="en-GB" dirty="0"/>
-              <a:t>the unit of measurement of data information.</a:t>
+            <a:pPr>
+              <a:spcAft>
+                <a:spcPts val="600"/>
+              </a:spcAft>
+              <a:defRPr sz="2300"/>
+            </a:pPr>
+            <a:r>
+              <a:t>One byte can store one standard ASCII character</a:t>
             </a:r>
           </a:p>
           <a:p>
-            <a:r>
-              <a:rPr lang="en-GB" dirty="0"/>
-              <a:t>Byte 8-bit collections</a:t>
-            </a:r>
-          </a:p>
-          <a:p>
-            <a:pPr lvl="1"/>
-            <a:r>
-              <a:rPr lang="en-GB" dirty="0"/>
-              <a:t>A single bit holds so little information. </a:t>
-            </a:r>
-          </a:p>
-          <a:p>
-            <a:pPr lvl="1"/>
-            <a:r>
-              <a:rPr lang="en-GB" dirty="0"/>
-              <a:t>A byte holds one ASCII</a:t>
-            </a:r>
-          </a:p>
-          <a:p>
-            <a:endParaRPr lang="en-US" dirty="0"/>
+            <a:pPr>
+              <a:spcAft>
+                <a:spcPts val="600"/>
+              </a:spcAft>
+              <a:defRPr sz="2300"/>
+            </a:pPr>
+            <a:r>
+              <a:t>Forensics often examines data at the byte and hexadecimal level</a:t>
+            </a:r>
           </a:p>
         </p:txBody>
       </p:sp>
@@ -16454,19 +16465,11 @@
           <a:bodyPr/>
           <a:lstStyle/>
           <a:p>
-            <a:r>
-              <a:rPr lang="en-US" dirty="0"/>
-              <a:t>ASCII - </a:t>
-            </a:r>
-            <a:r>
-              <a:rPr lang="en-US" sz="2400" b="1" i="0" dirty="0">
-                <a:solidFill>
-                  <a:srgbClr val="202122"/>
-                </a:solidFill>
-                <a:effectLst/>
-                <a:latin typeface="Arial" panose="020B0604020202020204" pitchFamily="34" charset="0"/>
-              </a:rPr>
-              <a:t>American Standard Code for Information Interchange</a:t>
+            <a:pPr algn="l">
+              <a:defRPr sz="3600" b="0"/>
+            </a:pPr>
+            <a:r>
+              <a:t>ASCII Character Encoding</a:t>
             </a:r>
             <a:endParaRPr lang="en-US" dirty="0"/>
           </a:p>
@@ -16490,19 +16493,35 @@
         </p:nvSpPr>
         <p:spPr>
           <a:xfrm>
-            <a:off x="838200" y="1825624"/>
-            <a:ext cx="2876550" cy="1108075"/>
+            <a:off x="777240" y="1874519"/>
+            <a:ext cx="2971800" cy="1645920"/>
           </a:xfrm>
         </p:spPr>
         <p:txBody>
           <a:bodyPr>
-            <a:normAutofit fontScale="85000" lnSpcReduction="10000"/>
+            <a:normAutofit/>
           </a:bodyPr>
           <a:lstStyle/>
           <a:p>
-            <a:r>
-              <a:rPr lang="en-US" dirty="0"/>
-              <a:t>ASCII codes represent text in computing devices.</a:t>
+            <a:pPr>
+              <a:spcAft>
+                <a:spcPts val="500"/>
+              </a:spcAft>
+              <a:defRPr sz="1800"/>
+            </a:pPr>
+            <a:r>
+              <a:t>ASCII maps values 0–127 to characters.</a:t>
+            </a:r>
+          </a:p>
+          <a:p>
+            <a:pPr>
+              <a:spcAft>
+                <a:spcPts val="500"/>
+              </a:spcAft>
+              <a:defRPr sz="1800"/>
+            </a:pPr>
+            <a:r>
+              <a:t>Raw bytes can become readable text.</a:t>
             </a:r>
           </a:p>
         </p:txBody>
@@ -16606,8 +16625,8 @@
         </p:blipFill>
         <p:spPr>
           <a:xfrm>
-            <a:off x="3909457" y="0"/>
-            <a:ext cx="6834929" cy="6858000"/>
+            <a:off x="4874341" y="426129"/>
+            <a:ext cx="6091270" cy="6111831"/>
           </a:xfrm>
           <a:prstGeom prst="rect">
             <a:avLst/>
@@ -16636,7 +16655,7 @@
         </p:blipFill>
         <p:spPr>
           <a:xfrm>
-            <a:off x="426514" y="1705697"/>
+            <a:off x="1009076" y="2229264"/>
             <a:ext cx="2446544" cy="553935"/>
           </a:xfrm>
           <a:prstGeom prst="rect">
@@ -16658,7 +16677,7 @@
         </p:nvSpPr>
         <p:spPr>
           <a:xfrm>
-            <a:off x="3036816" y="1899138"/>
+            <a:off x="3619378" y="2422705"/>
             <a:ext cx="545124" cy="167054"/>
           </a:xfrm>
           <a:prstGeom prst="rightArrow">
@@ -16687,6 +16706,39 @@
           <a:p>
             <a:pPr algn="ctr"/>
             <a:endParaRPr lang="en-US"/>
+          </a:p>
+        </p:txBody>
+      </p:sp>
+      <p:sp>
+        <p:nvSpPr>
+          <p:cNvPr id="2" name="Title 1">
+            <a:extLst>
+              <a:ext uri="{FF2B5EF4-FFF2-40B4-BE49-F238E27FC236}">
+                <a16:creationId xmlns:a16="http://schemas.microsoft.com/office/drawing/2014/main" id="{454F5840-3277-FB38-5F06-B1E334016CA6}"/>
+              </a:ext>
+            </a:extLst>
+          </p:cNvPr>
+          <p:cNvSpPr>
+            <a:spLocks noGrp="1"/>
+          </p:cNvSpPr>
+          <p:nvPr>
+            <p:ph type="title"/>
+          </p:nvPr>
+        </p:nvSpPr>
+        <p:spPr>
+          <a:xfrm>
+            <a:off x="838200" y="365125"/>
+            <a:ext cx="4036141" cy="1325563"/>
+          </a:xfrm>
+        </p:spPr>
+        <p:txBody>
+          <a:bodyPr/>
+          <a:lstStyle/>
+          <a:p>
+            <a:r>
+              <a:rPr lang="en-US" dirty="0"/>
+              <a:t>ASCII Table in Linux</a:t>
+            </a:r>
           </a:p>
         </p:txBody>
       </p:sp>
@@ -16741,8 +16793,10 @@
           <a:bodyPr/>
           <a:lstStyle/>
           <a:p>
-            <a:r>
-              <a:rPr lang="en-US" dirty="0"/>
+            <a:pPr algn="l">
+              <a:defRPr sz="3600" b="0"/>
+            </a:pPr>
+            <a:r>
               <a:t>Overview</a:t>
             </a:r>
           </a:p>
@@ -16769,31 +16823,64 @@
           <a:bodyPr/>
           <a:lstStyle/>
           <a:p>
-            <a:r>
-              <a:rPr lang="en-US" dirty="0"/>
-              <a:t>Number systems</a:t>
+            <a:pPr>
+              <a:spcAft>
+                <a:spcPts val="600"/>
+              </a:spcAft>
+              <a:defRPr sz="2600"/>
+            </a:pPr>
+            <a:r>
+              <a:rPr dirty="0"/>
+              <a:t>Why number systems matter in digital forensics</a:t>
             </a:r>
           </a:p>
           <a:p>
-            <a:r>
-              <a:rPr lang="en-US" dirty="0"/>
-              <a:t>American Standard Code for Information Interchange (ASCII code)</a:t>
+            <a:pPr>
+              <a:spcAft>
+                <a:spcPts val="600"/>
+              </a:spcAft>
+              <a:defRPr sz="2600"/>
+            </a:pPr>
+            <a:r>
+              <a:rPr dirty="0"/>
+              <a:t>Decimal, binary, and hexadecimal conversion</a:t>
             </a:r>
           </a:p>
           <a:p>
-            <a:r>
-              <a:rPr lang="en-US" dirty="0"/>
-              <a:t>Epoch time and timestamps</a:t>
+            <a:pPr>
+              <a:spcAft>
+                <a:spcPts val="600"/>
+              </a:spcAft>
+              <a:defRPr sz="2600"/>
+            </a:pPr>
+            <a:r>
+              <a:rPr dirty="0"/>
+              <a:t>ASCII, Unicode, and byte-level text interpretation</a:t>
             </a:r>
           </a:p>
           <a:p>
-            <a:r>
-              <a:rPr lang="en-US" dirty="0"/>
-              <a:t>Data stored in memory </a:t>
+            <a:pPr>
+              <a:spcAft>
+                <a:spcPts val="600"/>
+              </a:spcAft>
+              <a:defRPr sz="2600"/>
+            </a:pPr>
+            <a:r>
+              <a:rPr dirty="0"/>
+              <a:t>Epoch time, timestamp units, and time zones</a:t>
             </a:r>
           </a:p>
           <a:p>
-            <a:endParaRPr lang="en-US" dirty="0"/>
+            <a:pPr>
+              <a:spcAft>
+                <a:spcPts val="600"/>
+              </a:spcAft>
+              <a:defRPr sz="2600"/>
+            </a:pPr>
+            <a:r>
+              <a:rPr dirty="0"/>
+              <a:t>Endianness and hashing for evidence integrity</a:t>
+            </a:r>
           </a:p>
         </p:txBody>
       </p:sp>
@@ -16848,9 +16935,12 @@
           <a:bodyPr/>
           <a:lstStyle/>
           <a:p>
-            <a:r>
-              <a:rPr lang="en-US" dirty="0"/>
-              <a:t>Number and ASCII conversion (CLI)</a:t>
+            <a:pPr algn="l">
+              <a:defRPr sz="3600" b="0"/>
+            </a:pPr>
+            <a:r>
+              <a:rPr dirty="0"/>
+              <a:t>Number and ASCII Conversion in the CLI</a:t>
             </a:r>
           </a:p>
         </p:txBody>
@@ -17603,21 +17693,11 @@
           <a:bodyPr/>
           <a:lstStyle/>
           <a:p>
-            <a:r>
-              <a:rPr lang="en-US" dirty="0"/>
-              <a:t>Decimal and ASCII </a:t>
-            </a:r>
-            <a:r>
-              <a:rPr lang="en-US" b="1" dirty="0">
-                <a:solidFill>
-                  <a:srgbClr val="FF0000"/>
-                </a:solidFill>
-              </a:rPr>
-              <a:t>char</a:t>
-            </a:r>
-            <a:r>
-              <a:rPr lang="en-US" dirty="0"/>
-              <a:t> conversion (Python version)</a:t>
+            <a:pPr algn="l">
+              <a:defRPr sz="3400" b="0"/>
+            </a:pPr>
+            <a:r>
+              <a:t>Decimal and ASCII Character Conversion in Python</a:t>
             </a:r>
           </a:p>
         </p:txBody>
@@ -18022,9 +18102,11 @@
           <a:bodyPr/>
           <a:lstStyle/>
           <a:p>
-            <a:r>
-              <a:rPr lang="en-US" dirty="0"/>
-              <a:t>Hex and ASCII conversion (Python version)</a:t>
+            <a:pPr algn="l">
+              <a:defRPr sz="3600" b="0"/>
+            </a:pPr>
+            <a:r>
+              <a:t>Hex and ASCII Conversion in Python</a:t>
             </a:r>
           </a:p>
         </p:txBody>
@@ -19070,7 +19152,7 @@
                   <a:srgbClr val="FF0000"/>
                 </a:solidFill>
               </a:rPr>
-              <a:t>Python 2</a:t>
+              <a:t>Python 2 (legacy)</a:t>
             </a:r>
           </a:p>
         </p:txBody>
@@ -19155,7 +19237,7 @@
                   <a:srgbClr val="FF0000"/>
                 </a:solidFill>
               </a:rPr>
-              <a:t>Python 3</a:t>
+              <a:t>Python 3 (preferred)</a:t>
             </a:r>
           </a:p>
         </p:txBody>
@@ -19200,72 +19282,6 @@
       </p:grpSpPr>
       <p:sp>
         <p:nvSpPr>
-          <p:cNvPr id="9" name="Down Arrow 7">
-            <a:extLst>
-              <a:ext uri="{FF2B5EF4-FFF2-40B4-BE49-F238E27FC236}">
-                <a16:creationId xmlns:a16="http://schemas.microsoft.com/office/drawing/2014/main" id="{D4771268-CB57-404A-9271-370EB28F6090}"/>
-              </a:ext>
-              <a:ext uri="{C183D7F6-B498-43B3-948B-1728B52AA6E4}">
-                <adec:decorative xmlns:adec="http://schemas.microsoft.com/office/drawing/2017/decorative" val="1"/>
-              </a:ext>
-            </a:extLst>
-          </p:cNvPr>
-          <p:cNvSpPr>
-            <a:spLocks noGrp="1" noRot="1" noChangeAspect="1" noMove="1" noResize="1" noEditPoints="1" noAdjustHandles="1" noChangeArrowheads="1" noChangeShapeType="1" noTextEdit="1"/>
-          </p:cNvSpPr>
-          <p:nvPr>
-            <p:extLst>
-              <p:ext uri="{386F3935-93C4-4BCD-93E2-E3B085C9AB24}">
-                <p16:designElem xmlns:p16="http://schemas.microsoft.com/office/powerpoint/2015/main" val="1"/>
-              </p:ext>
-            </p:extLst>
-          </p:nvPr>
-        </p:nvSpPr>
-        <p:spPr>
-          <a:xfrm rot="16200000">
-            <a:off x="800100" y="1491343"/>
-            <a:ext cx="3333749" cy="3499103"/>
-          </a:xfrm>
-          <a:prstGeom prst="downArrow">
-            <a:avLst>
-              <a:gd name="adj1" fmla="val 100000"/>
-              <a:gd name="adj2" fmla="val 15788"/>
-            </a:avLst>
-          </a:prstGeom>
-          <a:solidFill>
-            <a:srgbClr val="404040"/>
-          </a:solidFill>
-          <a:ln w="53975">
-            <a:noFill/>
-          </a:ln>
-        </p:spPr>
-        <p:style>
-          <a:lnRef idx="2">
-            <a:schemeClr val="accent1">
-              <a:shade val="50000"/>
-            </a:schemeClr>
-          </a:lnRef>
-          <a:fillRef idx="1">
-            <a:schemeClr val="accent1"/>
-          </a:fillRef>
-          <a:effectRef idx="0">
-            <a:schemeClr val="accent1"/>
-          </a:effectRef>
-          <a:fontRef idx="minor">
-            <a:schemeClr val="lt1"/>
-          </a:fontRef>
-        </p:style>
-        <p:txBody>
-          <a:bodyPr rtlCol="0" anchor="ctr"/>
-          <a:lstStyle/>
-          <a:p>
-            <a:pPr algn="ctr"/>
-            <a:endParaRPr lang="en-US"/>
-          </a:p>
-        </p:txBody>
-      </p:sp>
-      <p:sp>
-        <p:nvSpPr>
           <p:cNvPr id="2" name="Title 1">
             <a:extLst>
               <a:ext uri="{FF2B5EF4-FFF2-40B4-BE49-F238E27FC236}">
@@ -19281,10 +19297,6 @@
           </p:nvPr>
         </p:nvSpPr>
         <p:spPr>
-          <a:xfrm>
-            <a:off x="1028700" y="1967266"/>
-            <a:ext cx="2628900" cy="2547257"/>
-          </a:xfrm>
           <a:noFill/>
         </p:spPr>
         <p:txBody>
@@ -19293,15 +19305,55 @@
           </a:bodyPr>
           <a:lstStyle/>
           <a:p>
-            <a:pPr algn="ctr"/>
-            <a:r>
-              <a:rPr lang="en-US" sz="3600" dirty="0">
-                <a:solidFill>
-                  <a:srgbClr val="FFFFFF"/>
-                </a:solidFill>
-              </a:rPr>
+            <a:pPr>
+              <a:defRPr sz="3200" b="0"/>
+            </a:pPr>
+            <a:r>
+              <a:rPr sz="3600" dirty="0"/>
               <a:t>Unicode</a:t>
             </a:r>
+          </a:p>
+        </p:txBody>
+      </p:sp>
+      <p:sp>
+        <p:nvSpPr>
+          <p:cNvPr id="3" name="Content Placeholder 2">
+            <a:extLst>
+              <a:ext uri="{FF2B5EF4-FFF2-40B4-BE49-F238E27FC236}">
+                <a16:creationId xmlns:a16="http://schemas.microsoft.com/office/drawing/2014/main" id="{2042E046-EEAD-5BC7-62A3-8E22DCFBB9A7}"/>
+              </a:ext>
+            </a:extLst>
+          </p:cNvPr>
+          <p:cNvSpPr>
+            <a:spLocks noGrp="1"/>
+          </p:cNvSpPr>
+          <p:nvPr>
+            <p:ph idx="1"/>
+          </p:nvPr>
+        </p:nvSpPr>
+        <p:spPr>
+          <a:xfrm>
+            <a:off x="838200" y="1825625"/>
+            <a:ext cx="6594987" cy="4351338"/>
+          </a:xfrm>
+        </p:spPr>
+        <p:txBody>
+          <a:bodyPr/>
+          <a:lstStyle/>
+          <a:p>
+            <a:r>
+              <a:rPr lang="en-GB" dirty="0"/>
+              <a:t>Unicode assigns code points to characters from many writing systems. Encoding forms such as UTF-8 and UTF-16 store those code points as bytes. </a:t>
+            </a:r>
+          </a:p>
+          <a:p>
+            <a:r>
+              <a:rPr lang="en-GB" dirty="0"/>
+              <a:t>In forensics, the correct encoding determines whether recovered text is readable.</a:t>
+            </a:r>
+          </a:p>
+          <a:p>
+            <a:endParaRPr lang="en-US" dirty="0"/>
           </a:p>
         </p:txBody>
       </p:sp>
@@ -19335,101 +19387,6 @@
           </a:prstGeom>
         </p:spPr>
       </p:pic>
-      <p:sp>
-        <p:nvSpPr>
-          <p:cNvPr id="6" name="TextBox 5">
-            <a:extLst>
-              <a:ext uri="{FF2B5EF4-FFF2-40B4-BE49-F238E27FC236}">
-                <a16:creationId xmlns:a16="http://schemas.microsoft.com/office/drawing/2014/main" id="{06DB8224-7278-7473-B6EA-2C8E9E75DEFD}"/>
-              </a:ext>
-            </a:extLst>
-          </p:cNvPr>
-          <p:cNvSpPr txBox="1"/>
-          <p:nvPr/>
-        </p:nvSpPr>
-        <p:spPr>
-          <a:xfrm>
-            <a:off x="4330185" y="1342170"/>
-            <a:ext cx="4853873" cy="3354765"/>
-          </a:xfrm>
-          <a:prstGeom prst="rect">
-            <a:avLst/>
-          </a:prstGeom>
-          <a:noFill/>
-        </p:spPr>
-        <p:txBody>
-          <a:bodyPr wrap="square">
-            <a:spAutoFit/>
-          </a:bodyPr>
-          <a:lstStyle/>
-          <a:p>
-            <a:r>
-              <a:rPr lang="en-GB" sz="2400" b="1" dirty="0"/>
-              <a:t>Unicode</a:t>
-            </a:r>
-            <a:r>
-              <a:rPr lang="en-GB" sz="2400" dirty="0"/>
-              <a:t>, formally The Unicode Standard is an information technology </a:t>
-            </a:r>
-            <a:r>
-              <a:rPr lang="en-GB" sz="2400" b="1" dirty="0"/>
-              <a:t>standard</a:t>
-            </a:r>
-            <a:r>
-              <a:rPr lang="en-GB" sz="2400" dirty="0"/>
-              <a:t> for the consistent </a:t>
-            </a:r>
-            <a:r>
-              <a:rPr lang="en-GB" sz="2400" dirty="0">
-                <a:solidFill>
-                  <a:srgbClr val="FF0000"/>
-                </a:solidFill>
-              </a:rPr>
-              <a:t>encoding</a:t>
-            </a:r>
-            <a:r>
-              <a:rPr lang="en-GB" sz="2400" dirty="0"/>
-              <a:t>, </a:t>
-            </a:r>
-            <a:r>
-              <a:rPr lang="en-GB" sz="2400" dirty="0">
-                <a:solidFill>
-                  <a:srgbClr val="FF0000"/>
-                </a:solidFill>
-              </a:rPr>
-              <a:t>representation</a:t>
-            </a:r>
-            <a:r>
-              <a:rPr lang="en-GB" sz="2400" dirty="0"/>
-              <a:t>, and handling of text expressed in most of the </a:t>
-            </a:r>
-            <a:r>
-              <a:rPr lang="en-GB" sz="2400" dirty="0">
-                <a:solidFill>
-                  <a:srgbClr val="FF0000"/>
-                </a:solidFill>
-              </a:rPr>
-              <a:t>world's</a:t>
-            </a:r>
-            <a:r>
-              <a:rPr lang="en-GB" sz="2400" dirty="0"/>
-              <a:t> writing systems. </a:t>
-            </a:r>
-          </a:p>
-          <a:p>
-            <a:endParaRPr lang="en-GB" sz="2400" dirty="0"/>
-          </a:p>
-          <a:p>
-            <a:endParaRPr lang="en-GB" sz="2400" dirty="0"/>
-          </a:p>
-          <a:p>
-            <a:r>
-              <a:rPr lang="en-US" sz="2000" dirty="0"/>
-              <a:t>https://en.wikipedia.org/wiki/Unicode</a:t>
-            </a:r>
-          </a:p>
-        </p:txBody>
-      </p:sp>
     </p:spTree>
     <p:extLst>
       <p:ext uri="{BB962C8B-B14F-4D97-AF65-F5344CB8AC3E}">
@@ -19481,9 +19438,11 @@
           <a:bodyPr/>
           <a:lstStyle/>
           <a:p>
-            <a:r>
-              <a:rPr lang="en-GB" dirty="0"/>
-              <a:t>What's the difference between ASCII and UTF-8 Unicode?</a:t>
+            <a:pPr algn="l">
+              <a:defRPr sz="3600" b="0"/>
+            </a:pPr>
+            <a:r>
+              <a:t>ASCII vs. UTF-8</a:t>
             </a:r>
             <a:endParaRPr lang="en-US" dirty="0"/>
           </a:p>
@@ -19508,69 +19467,63 @@
         <p:spPr/>
         <p:txBody>
           <a:bodyPr>
-            <a:normAutofit lnSpcReduction="10000"/>
+            <a:normAutofit/>
           </a:bodyPr>
           <a:lstStyle/>
           <a:p>
-            <a:r>
-              <a:rPr lang="en-GB" dirty="0"/>
-              <a:t>Both are character encoding standards used for representing characters</a:t>
+            <a:pPr>
+              <a:spcAft>
+                <a:spcPts val="600"/>
+              </a:spcAft>
+              <a:defRPr sz="2400"/>
+            </a:pPr>
+            <a:r>
+              <a:t>ASCII: 7-bit encoding for 128 values</a:t>
             </a:r>
           </a:p>
           <a:p>
-            <a:pPr lvl="1"/>
-            <a:r>
-              <a:rPr lang="en-GB" dirty="0"/>
-              <a:t>letters, numbers, symbols, etc.</a:t>
+            <a:pPr>
+              <a:spcAft>
+                <a:spcPts val="600"/>
+              </a:spcAft>
+              <a:defRPr sz="2400"/>
+            </a:pPr>
+            <a:r>
+              <a:t>UTF-8: variable-length encoding for Unicode</a:t>
             </a:r>
           </a:p>
           <a:p>
-            <a:pPr lvl="1"/>
-            <a:r>
-              <a:rPr lang="en-GB" dirty="0"/>
-              <a:t>use a series of bits (1s and 0s). </a:t>
+            <a:pPr>
+              <a:spcAft>
+                <a:spcPts val="600"/>
+              </a:spcAft>
+              <a:defRPr sz="2400"/>
+            </a:pPr>
+            <a:r>
+              <a:t>UTF-8 preserves ASCII byte values for 0–127</a:t>
             </a:r>
           </a:p>
           <a:p>
-            <a:r>
-              <a:rPr lang="en-GB" dirty="0"/>
-              <a:t>Length difference</a:t>
+            <a:pPr>
+              <a:spcAft>
+                <a:spcPts val="600"/>
+              </a:spcAft>
+              <a:defRPr sz="2400"/>
+            </a:pPr>
+            <a:r>
+              <a:t>UTF-8 can represent non-English characters and symbols</a:t>
             </a:r>
           </a:p>
           <a:p>
-            <a:pPr lvl="1"/>
-            <a:r>
-              <a:rPr lang="en-GB" dirty="0"/>
-              <a:t>ASCII uses 7 bits (128 characters)</a:t>
-            </a:r>
-          </a:p>
-          <a:p>
-            <a:pPr lvl="1"/>
-            <a:r>
-              <a:rPr lang="en-GB" dirty="0"/>
-              <a:t>UTF-8 uses variable-length encoding (1,112,064 characters)</a:t>
-            </a:r>
-          </a:p>
-          <a:p>
-            <a:r>
-              <a:rPr lang="en-GB" dirty="0"/>
-              <a:t>UTF-8 is a superset of ASCII</a:t>
-            </a:r>
-          </a:p>
-          <a:p>
-            <a:pPr lvl="1"/>
-            <a:r>
-              <a:rPr lang="en-GB" dirty="0"/>
-              <a:t>all ASCII characters have the same representation in UTF-8. </a:t>
-            </a:r>
-          </a:p>
-          <a:p>
-            <a:pPr lvl="1"/>
-            <a:r>
-              <a:rPr lang="en-GB" dirty="0"/>
-              <a:t>UTF-8 can represent a wider range of characters, including non-English characters</a:t>
-            </a:r>
-            <a:endParaRPr lang="en-US" dirty="0"/>
+            <a:pPr>
+              <a:spcAft>
+                <a:spcPts val="600"/>
+              </a:spcAft>
+              <a:defRPr sz="2400"/>
+            </a:pPr>
+            <a:r>
+              <a:t>Forensic implication: decode bytes with the correct character encoding</a:t>
+            </a:r>
           </a:p>
         </p:txBody>
       </p:sp>
@@ -19625,9 +19578,11 @@
           <a:bodyPr/>
           <a:lstStyle/>
           <a:p>
-            <a:r>
-              <a:rPr lang="en-US" dirty="0"/>
-              <a:t>Epoch time and timestamps</a:t>
+            <a:pPr algn="l">
+              <a:defRPr sz="4400" b="0"/>
+            </a:pPr>
+            <a:r>
+              <a:t>Epoch Time and Timestamps</a:t>
             </a:r>
           </a:p>
         </p:txBody>
@@ -19653,9 +19608,15 @@
           <a:bodyPr/>
           <a:lstStyle/>
           <a:p>
-            <a:r>
-              <a:rPr lang="en-US" dirty="0"/>
-              <a:t>-different timestamp formats</a:t>
+            <a:pPr algn="l">
+              <a:defRPr sz="2000">
+                <a:solidFill>
+                  <a:srgbClr val="787878"/>
+                </a:solidFill>
+              </a:defRPr>
+            </a:pPr>
+            <a:r>
+              <a:t>Different formats can use different epochs, units, and time zones.</a:t>
             </a:r>
           </a:p>
         </p:txBody>
@@ -19711,9 +19672,12 @@
           <a:bodyPr/>
           <a:lstStyle/>
           <a:p>
-            <a:r>
-              <a:rPr lang="en-US" dirty="0"/>
-              <a:t>Epoch time </a:t>
+            <a:pPr algn="l">
+              <a:defRPr sz="3600" b="0"/>
+            </a:pPr>
+            <a:r>
+              <a:rPr lang="en-US"/>
+              <a:t>Epoch Time</a:t>
             </a:r>
           </a:p>
         </p:txBody>
@@ -19737,104 +19701,120 @@
         <p:spPr/>
         <p:txBody>
           <a:bodyPr>
-            <a:normAutofit lnSpcReduction="10000"/>
+            <a:normAutofit/>
           </a:bodyPr>
           <a:lstStyle/>
           <a:p>
-            <a:r>
-              <a:rPr lang="en-GB" dirty="0"/>
-              <a:t>Epoch time is a way to represent time as the number of seconds or milliseconds that have passed since a specific starting point, known as the epoch</a:t>
+            <a:pPr>
+              <a:spcAft>
+                <a:spcPts val="600"/>
+              </a:spcAft>
+              <a:defRPr sz="2000"/>
+            </a:pPr>
+            <a:r>
+              <a:rPr lang="en-US" dirty="0"/>
+              <a:t>Epoch time stores time as elapsed units from a defined start date.</a:t>
             </a:r>
           </a:p>
           <a:p>
-            <a:pPr lvl="1"/>
-            <a:r>
-              <a:rPr lang="en-GB" dirty="0"/>
-              <a:t>1 second = 1,000 milliseconds (</a:t>
-            </a:r>
-            <a:r>
-              <a:rPr lang="en-GB" dirty="0" err="1"/>
-              <a:t>ms</a:t>
-            </a:r>
-            <a:r>
-              <a:rPr lang="en-GB" dirty="0"/>
-              <a:t>)</a:t>
+            <a:pPr>
+              <a:spcAft>
+                <a:spcPts val="600"/>
+              </a:spcAft>
+              <a:defRPr sz="2000"/>
+            </a:pPr>
+            <a:r>
+              <a:rPr lang="en-US" dirty="0"/>
+              <a:t>Common units: seconds, milliseconds (10</a:t>
+            </a:r>
+            <a:r>
+              <a:rPr lang="en-US" baseline="30000" dirty="0"/>
+              <a:t>3</a:t>
+            </a:r>
+            <a:r>
+              <a:rPr lang="en-US" dirty="0"/>
+              <a:t>) microseconds (10</a:t>
+            </a:r>
+            <a:r>
+              <a:rPr lang="en-US" baseline="30000" dirty="0"/>
+              <a:t>6</a:t>
+            </a:r>
+            <a:r>
+              <a:rPr lang="en-US" dirty="0"/>
+              <a:t>) , nanoseconds.</a:t>
             </a:r>
           </a:p>
           <a:p>
-            <a:pPr lvl="1"/>
-            <a:r>
-              <a:rPr lang="en-GB" dirty="0"/>
-              <a:t>1 second = 1,000,000 microseconds (µs)</a:t>
+            <a:pPr>
+              <a:spcAft>
+                <a:spcPts val="600"/>
+              </a:spcAft>
+              <a:defRPr sz="2000"/>
+            </a:pPr>
+            <a:r>
+              <a:rPr lang="en-US" dirty="0"/>
+              <a:t>Unix/POSIX: seconds since 1970-01-01 UTC</a:t>
             </a:r>
           </a:p>
           <a:p>
-            <a:r>
-              <a:rPr lang="en-GB" dirty="0"/>
-              <a:t>Types of epoch time</a:t>
+            <a:pPr>
+              <a:spcAft>
+                <a:spcPts val="600"/>
+              </a:spcAft>
+              <a:defRPr sz="2000"/>
+            </a:pPr>
+            <a:r>
+              <a:rPr lang="en-US" dirty="0"/>
+              <a:t>Cocoa/Core Data: seconds since 2001-01-01 UTC</a:t>
             </a:r>
           </a:p>
           <a:p>
-            <a:pPr lvl="1"/>
-            <a:r>
-              <a:rPr lang="en-GB" dirty="0"/>
-              <a:t>Unix Epoch Time </a:t>
-            </a:r>
+            <a:pPr>
+              <a:spcAft>
+                <a:spcPts val="600"/>
+              </a:spcAft>
+              <a:defRPr sz="2000"/>
+            </a:pPr>
             <a:r>
               <a:rPr lang="en-US" dirty="0"/>
-              <a:t>(POSIX Time) - </a:t>
-            </a:r>
-            <a:r>
-              <a:rPr lang="en-US" b="0" i="0" dirty="0">
-                <a:solidFill>
-                  <a:srgbClr val="374151"/>
-                </a:solidFill>
-                <a:effectLst/>
-                <a:latin typeface="Söhne"/>
-              </a:rPr>
-              <a:t>1970 </a:t>
-            </a:r>
-            <a:endParaRPr lang="en-GB" dirty="0"/>
+              <a:t>HFS+: seconds since 1904-01-01 UTC</a:t>
+            </a:r>
           </a:p>
           <a:p>
-            <a:pPr lvl="1"/>
-            <a:r>
-              <a:rPr lang="en-GB" dirty="0"/>
-              <a:t>Mac Time: Mac OS X Time/ Cocoa Core Date – 2001; </a:t>
-            </a:r>
+            <a:pPr>
+              <a:spcAft>
+                <a:spcPts val="600"/>
+              </a:spcAft>
+              <a:defRPr sz="2000"/>
+            </a:pPr>
             <a:r>
               <a:rPr lang="en-US" dirty="0"/>
-              <a:t>HFS+/APFS - 1904</a:t>
+              <a:t>WebKit/Chrome: microseconds since 1601-01-01 UTC</a:t>
             </a:r>
           </a:p>
           <a:p>
-            <a:pPr lvl="1"/>
-            <a:r>
-              <a:rPr lang="en-GB" dirty="0"/>
-              <a:t>WebKit time - 1601</a:t>
+            <a:pPr>
+              <a:spcAft>
+                <a:spcPts val="600"/>
+              </a:spcAft>
+              <a:defRPr sz="2000"/>
+            </a:pPr>
+            <a:r>
+              <a:rPr lang="en-US" dirty="0"/>
+              <a:t>Windows FILETIME: 100-ns intervals since 1601-01-01 UTC</a:t>
             </a:r>
           </a:p>
           <a:p>
-            <a:pPr lvl="1"/>
-            <a:r>
-              <a:rPr lang="en-GB" dirty="0"/>
-              <a:t>Windows </a:t>
-            </a:r>
-            <a:r>
-              <a:rPr lang="en-GB" dirty="0" err="1"/>
-              <a:t>Filetime</a:t>
-            </a:r>
-            <a:r>
-              <a:rPr lang="en-GB" dirty="0"/>
-              <a:t> - 1601</a:t>
-            </a:r>
-          </a:p>
-          <a:p>
-            <a:r>
-              <a:rPr lang="en-GB" dirty="0"/>
-              <a:t>Understand epoch time is important for digital forensics</a:t>
-            </a:r>
-            <a:endParaRPr lang="en-US" dirty="0"/>
+            <a:pPr>
+              <a:spcAft>
+                <a:spcPts val="600"/>
+              </a:spcAft>
+              <a:defRPr sz="2000"/>
+            </a:pPr>
+            <a:r>
+              <a:rPr lang="en-US" dirty="0"/>
+              <a:t>Forensics: document epoch, unit, and time zone.</a:t>
+            </a:r>
           </a:p>
         </p:txBody>
       </p:sp>
@@ -19889,9 +19869,11 @@
           <a:bodyPr/>
           <a:lstStyle/>
           <a:p>
-            <a:r>
-              <a:rPr lang="en-GB" dirty="0"/>
-              <a:t>Unix time</a:t>
+            <a:pPr algn="l">
+              <a:defRPr sz="3600" b="0"/>
+            </a:pPr>
+            <a:r>
+              <a:t>Unix Time</a:t>
             </a:r>
             <a:endParaRPr lang="en-US" dirty="0"/>
           </a:p>
@@ -19920,54 +19902,53 @@
           </a:xfrm>
         </p:spPr>
         <p:txBody>
-          <a:bodyPr/>
+          <a:bodyPr>
+            <a:normAutofit fontScale="92500" lnSpcReduction="20000"/>
+          </a:bodyPr>
           <a:lstStyle/>
           <a:p>
-            <a:r>
-              <a:rPr lang="en-GB" dirty="0"/>
-              <a:t>Unix time, or POSIX time, is a system for describing points in time. </a:t>
+            <a:pPr>
+              <a:spcAft>
+                <a:spcPts val="600"/>
+              </a:spcAft>
+              <a:defRPr sz="2400"/>
+            </a:pPr>
+            <a:r>
+              <a:t>Unix/POSIX time represents a point in time as elapsed seconds.</a:t>
             </a:r>
           </a:p>
           <a:p>
-            <a:r>
-              <a:rPr lang="en-GB" dirty="0"/>
-              <a:t>It is the number of </a:t>
-            </a:r>
-            <a:r>
-              <a:rPr lang="en-GB" dirty="0">
-                <a:solidFill>
-                  <a:srgbClr val="FF0000"/>
-                </a:solidFill>
-              </a:rPr>
-              <a:t>seconds</a:t>
-            </a:r>
-            <a:r>
-              <a:rPr lang="en-GB" dirty="0"/>
-              <a:t> that have elapsed since the Unix epoch,</a:t>
+            <a:pPr>
+              <a:spcAft>
+                <a:spcPts val="600"/>
+              </a:spcAft>
+              <a:defRPr sz="2400"/>
+            </a:pPr>
+            <a:r>
+              <a:t>Epoch: 1970-01-01 00:00:00 UTC.</a:t>
             </a:r>
           </a:p>
           <a:p>
-            <a:r>
-              <a:rPr lang="en-GB" dirty="0"/>
-              <a:t>The Unix epoch is 00:00:00 </a:t>
-            </a:r>
-            <a:r>
-              <a:rPr lang="en-GB" dirty="0">
-                <a:hlinkClick r:id="rId3" tooltip="Coordinated Universal Time">
-                  <a:extLst>
-                    <a:ext uri="{A12FA001-AC4F-418D-AE19-62706E023703}">
-                      <ahyp:hlinkClr xmlns:ahyp="http://schemas.microsoft.com/office/drawing/2018/hyperlinkcolor" val="tx"/>
-                    </a:ext>
-                  </a:extLst>
-                </a:hlinkClick>
-              </a:rPr>
-              <a:t>UTC</a:t>
-            </a:r>
-            <a:r>
-              <a:rPr lang="en-GB" dirty="0"/>
-              <a:t> on 1 January 1970 </a:t>
-            </a:r>
-            <a:endParaRPr lang="en-US" dirty="0"/>
+            <a:pPr>
+              <a:spcAft>
+                <a:spcPts val="600"/>
+              </a:spcAft>
+              <a:defRPr sz="2400"/>
+            </a:pPr>
+            <a:r>
+              <a:t>Convert using CLI, Python, or forensic tools.</a:t>
+            </a:r>
+          </a:p>
+          <a:p>
+            <a:pPr>
+              <a:spcAft>
+                <a:spcPts val="600"/>
+              </a:spcAft>
+              <a:defRPr sz="2400"/>
+            </a:pPr>
+            <a:r>
+              <a:t>Always distinguish UTC from local time.</a:t>
+            </a:r>
           </a:p>
         </p:txBody>
       </p:sp>
@@ -19986,7 +19967,7 @@
           <p:nvPr/>
         </p:nvPicPr>
         <p:blipFill>
-          <a:blip r:embed="rId4"/>
+          <a:blip r:embed="rId3"/>
           <a:stretch>
             <a:fillRect/>
           </a:stretch>
@@ -20016,7 +19997,7 @@
           <p:nvPr/>
         </p:nvPicPr>
         <p:blipFill>
-          <a:blip r:embed="rId5"/>
+          <a:blip r:embed="rId4"/>
           <a:stretch>
             <a:fillRect/>
           </a:stretch>
@@ -20063,7 +20044,7 @@
           <a:p>
             <a:r>
               <a:rPr lang="en-US" dirty="0"/>
-              <a:t>Current time to Unix time</a:t>
+              <a:t>Current time → Unix time</a:t>
             </a:r>
           </a:p>
         </p:txBody>
@@ -20100,7 +20081,7 @@
           <a:p>
             <a:r>
               <a:rPr lang="en-US" dirty="0"/>
-              <a:t>Unix time to readable time</a:t>
+              <a:t>Unix time → readable time</a:t>
             </a:r>
           </a:p>
         </p:txBody>
@@ -20200,9 +20181,11 @@
           <a:bodyPr/>
           <a:lstStyle/>
           <a:p>
-            <a:r>
-              <a:rPr lang="en-GB" dirty="0"/>
-              <a:t>Unix time (Python version)</a:t>
+            <a:pPr algn="l">
+              <a:defRPr sz="3600" b="0"/>
+            </a:pPr>
+            <a:r>
+              <a:t>Unix Time in Python</a:t>
             </a:r>
             <a:endParaRPr lang="en-US" dirty="0"/>
           </a:p>
@@ -20312,82 +20295,48 @@
           <a:lstStyle/>
           <a:p>
             <a:pPr marL="285750" indent="-285750">
+              <a:spcAft>
+                <a:spcPts val="600"/>
+              </a:spcAft>
               <a:buFont typeface="Arial" panose="020B0604020202020204" pitchFamily="34" charset="0"/>
               <a:buChar char="•"/>
+              <a:defRPr sz="1800"/>
             </a:pPr>
             <a:r>
-              <a:rPr lang="en-GB" b="1" dirty="0"/>
-              <a:t>A Python module </a:t>
-            </a:r>
-            <a:r>
-              <a:rPr lang="en-GB" dirty="0"/>
-              <a:t>is a </a:t>
-            </a:r>
-            <a:r>
-              <a:rPr lang="en-GB" dirty="0">
-                <a:latin typeface="OCRB" panose="020B0609020202020204" pitchFamily="49" charset="0"/>
-              </a:rPr>
-              <a:t>.</a:t>
-            </a:r>
-            <a:r>
-              <a:rPr lang="en-GB" dirty="0" err="1">
-                <a:latin typeface="OCRB" panose="020B0609020202020204" pitchFamily="49" charset="0"/>
-              </a:rPr>
-              <a:t>py</a:t>
-            </a:r>
-            <a:r>
-              <a:rPr lang="en-GB" dirty="0">
-                <a:latin typeface="OCRB" panose="020B0609020202020204" pitchFamily="49" charset="0"/>
-              </a:rPr>
-              <a:t> </a:t>
-            </a:r>
-            <a:r>
-              <a:rPr lang="en-GB" dirty="0"/>
-              <a:t>file that contains Python code. </a:t>
+              <a:t>datetime represents a human-readable date and time.</a:t>
             </a:r>
           </a:p>
           <a:p>
-            <a:pPr marL="285750" indent="-285750">
-              <a:buFont typeface="Arial" panose="020B0604020202020204" pitchFamily="34" charset="0"/>
-              <a:buChar char="•"/>
+            <a:pPr>
+              <a:spcAft>
+                <a:spcPts val="600"/>
+              </a:spcAft>
+              <a:defRPr sz="1800"/>
             </a:pPr>
             <a:r>
-              <a:rPr lang="en-GB" b="1" dirty="0"/>
-              <a:t>A Python module </a:t>
-            </a:r>
-            <a:r>
-              <a:rPr lang="en-GB" dirty="0"/>
-              <a:t>contains multiple functions</a:t>
+              <a:t>timestamp() converts a timezone-aware datetime to Unix seconds.</a:t>
             </a:r>
           </a:p>
           <a:p>
-            <a:pPr marL="285750" indent="-285750">
-              <a:buFont typeface="Arial" panose="020B0604020202020204" pitchFamily="34" charset="0"/>
-              <a:buChar char="•"/>
+            <a:pPr>
+              <a:spcAft>
+                <a:spcPts val="600"/>
+              </a:spcAft>
+              <a:defRPr sz="1800"/>
             </a:pPr>
             <a:r>
-              <a:rPr lang="en-GB" dirty="0"/>
-              <a:t>Use keyword </a:t>
-            </a:r>
-            <a:r>
-              <a:rPr lang="en-GB" dirty="0">
-                <a:latin typeface="OCRB" panose="020B0609020202020204" pitchFamily="49" charset="0"/>
-              </a:rPr>
-              <a:t>from</a:t>
-            </a:r>
-            <a:r>
-              <a:rPr lang="en-GB" dirty="0"/>
-              <a:t> and </a:t>
-            </a:r>
-            <a:r>
-              <a:rPr lang="en-GB" dirty="0">
-                <a:latin typeface="OCRB" panose="020B0609020202020204" pitchFamily="49" charset="0"/>
-              </a:rPr>
-              <a:t>import</a:t>
-            </a:r>
-            <a:r>
-              <a:rPr lang="en-GB" dirty="0"/>
-              <a:t> if you only want to import a few functions,</a:t>
+              <a:t>datetime.fromtimestamp(ts, timezone.utc) returns UTC time.</a:t>
+            </a:r>
+          </a:p>
+          <a:p>
+            <a:pPr>
+              <a:spcAft>
+                <a:spcPts val="600"/>
+              </a:spcAft>
+              <a:defRPr sz="1800"/>
+            </a:pPr>
+            <a:r>
+              <a:t>Avoid mixing local time and UTC during evidence analysis.</a:t>
             </a:r>
           </a:p>
         </p:txBody>
@@ -20715,7 +20664,7 @@
           <a:p>
             <a:r>
               <a:rPr lang="en-US" dirty="0"/>
-              <a:t>timestamp is an integer, representing a time in second</a:t>
+              <a:t>A timestamp represents elapsed seconds.</a:t>
             </a:r>
           </a:p>
         </p:txBody>
@@ -21158,7 +21107,7 @@
                 <a:effectLst/>
                 <a:latin typeface="Inter-Regular"/>
               </a:rPr>
-              <a:t>Get the current time in a human-readable format</a:t>
+              <a:t>Human-readable time</a:t>
             </a:r>
             <a:endParaRPr lang="en-US" dirty="0"/>
           </a:p>
@@ -21402,6 +21351,37 @@
           </a:p>
         </p:txBody>
       </p:sp>
+      <p:sp>
+        <p:nvSpPr>
+          <p:cNvPr id="43" name="TextBox 42"/>
+          <p:cNvSpPr txBox="1"/>
+          <p:nvPr/>
+        </p:nvSpPr>
+        <p:spPr>
+          <a:xfrm>
+            <a:off x="731520" y="320040"/>
+            <a:ext cx="10698480" cy="502920"/>
+          </a:xfrm>
+          <a:prstGeom prst="rect">
+            <a:avLst/>
+          </a:prstGeom>
+          <a:noFill/>
+        </p:spPr>
+        <p:txBody>
+          <a:bodyPr wrap="none">
+            <a:spAutoFit/>
+          </a:bodyPr>
+          <a:lstStyle/>
+          <a:p>
+            <a:pPr>
+              <a:defRPr sz="3200" b="0"/>
+            </a:pPr>
+            <a:r>
+              <a:t>Getting Current Time in Python</a:t>
+            </a:r>
+          </a:p>
+        </p:txBody>
+      </p:sp>
     </p:spTree>
     <p:extLst>
       <p:ext uri="{BB962C8B-B14F-4D97-AF65-F5344CB8AC3E}">
@@ -21453,9 +21433,11 @@
           <a:bodyPr/>
           <a:lstStyle/>
           <a:p>
-            <a:r>
-              <a:rPr lang="en-US" dirty="0"/>
-              <a:t>Number systems</a:t>
+            <a:pPr algn="l">
+              <a:defRPr sz="4400" b="0"/>
+            </a:pPr>
+            <a:r>
+              <a:t>Number Systems</a:t>
             </a:r>
           </a:p>
         </p:txBody>
@@ -21577,7 +21559,7 @@
           <a:p>
             <a:r>
               <a:rPr lang="en-US" dirty="0"/>
-              <a:t>Covert seconds to a readable time (</a:t>
+              <a:t>Convert seconds to a readable time (</a:t>
             </a:r>
             <a:r>
               <a:rPr lang="en-US" dirty="0">
@@ -21948,53 +21930,37 @@
           </a:p>
         </p:txBody>
       </p:sp>
-      <p:pic>
-        <p:nvPicPr>
-          <p:cNvPr id="1028" name="Picture 4" descr="The trillion dollar question: what does a trillion look like? – The Irish  Times">
-            <a:extLst>
-              <a:ext uri="{FF2B5EF4-FFF2-40B4-BE49-F238E27FC236}">
-                <a16:creationId xmlns:a16="http://schemas.microsoft.com/office/drawing/2014/main" id="{977334E4-B9B3-4B33-4869-C0046387D5F7}"/>
-              </a:ext>
-            </a:extLst>
-          </p:cNvPr>
-          <p:cNvPicPr>
-            <a:picLocks noChangeAspect="1" noChangeArrowheads="1"/>
-          </p:cNvPicPr>
+      <p:sp>
+        <p:nvSpPr>
+          <p:cNvPr id="1029" name="TextBox 1028"/>
+          <p:cNvSpPr txBox="1"/>
           <p:nvPr/>
-        </p:nvPicPr>
-        <p:blipFill>
-          <a:blip r:embed="rId5">
-            <a:extLst>
-              <a:ext uri="{28A0092B-C50C-407E-A947-70E740481C1C}">
-                <a14:useLocalDpi xmlns:a14="http://schemas.microsoft.com/office/drawing/2010/main" val="0"/>
-              </a:ext>
-            </a:extLst>
-          </a:blip>
-          <a:srcRect/>
-          <a:stretch>
-            <a:fillRect/>
-          </a:stretch>
-        </p:blipFill>
-        <p:spPr bwMode="auto">
+        </p:nvSpPr>
+        <p:spPr>
           <a:xfrm>
-            <a:off x="8528250" y="66582"/>
-            <a:ext cx="3663750" cy="1950060"/>
+            <a:off x="731520" y="320040"/>
+            <a:ext cx="10698480" cy="502920"/>
           </a:xfrm>
           <a:prstGeom prst="rect">
             <a:avLst/>
           </a:prstGeom>
           <a:noFill/>
-          <a:extLst>
-            <a:ext uri="{909E8E84-426E-40DD-AFC4-6F175D3DCCD1}">
-              <a14:hiddenFill xmlns:a14="http://schemas.microsoft.com/office/drawing/2010/main">
-                <a:solidFill>
-                  <a:srgbClr val="FFFFFF"/>
-                </a:solidFill>
-              </a14:hiddenFill>
-            </a:ext>
-          </a:extLst>
         </p:spPr>
-      </p:pic>
+        <p:txBody>
+          <a:bodyPr wrap="none">
+            <a:spAutoFit/>
+          </a:bodyPr>
+          <a:lstStyle/>
+          <a:p>
+            <a:pPr>
+              <a:defRPr sz="3200" b="0"/>
+            </a:pPr>
+            <a:r>
+              <a:t>Converting Seconds to Readable Time</a:t>
+            </a:r>
+          </a:p>
+        </p:txBody>
+      </p:sp>
     </p:spTree>
     <p:extLst>
       <p:ext uri="{BB962C8B-B14F-4D97-AF65-F5344CB8AC3E}">
@@ -22046,9 +22012,11 @@
           <a:bodyPr/>
           <a:lstStyle/>
           <a:p>
-            <a:r>
-              <a:rPr lang="en-GB" dirty="0"/>
-              <a:t>Mac "epoch time"  - Cocoa Core Date </a:t>
+            <a:pPr algn="l">
+              <a:defRPr sz="3600" b="0"/>
+            </a:pPr>
+            <a:r>
+              <a:t>Mac Epoch Time: Cocoa/Core Data</a:t>
             </a:r>
             <a:endParaRPr lang="en-US" dirty="0"/>
           </a:p>
@@ -22075,88 +22043,47 @@
           <a:bodyPr/>
           <a:lstStyle/>
           <a:p>
-            <a:r>
-              <a:rPr lang="en-GB" dirty="0"/>
-              <a:t>Mac uses a different "epoch time" than the UNIX epoch time.</a:t>
+            <a:pPr>
+              <a:spcAft>
+                <a:spcPts val="600"/>
+              </a:spcAft>
+              <a:defRPr sz="2500"/>
+            </a:pPr>
+            <a:r>
+              <a:t>Cocoa/Core Data time uses seconds since 2001-01-01 00:00:00 UTC.</a:t>
             </a:r>
           </a:p>
           <a:p>
-            <a:pPr lvl="1"/>
-            <a:r>
-              <a:rPr lang="en-GB" dirty="0"/>
-              <a:t>Cocoa Core Date </a:t>
+            <a:pPr>
+              <a:spcAft>
+                <a:spcPts val="600"/>
+              </a:spcAft>
+              <a:defRPr sz="2500"/>
+            </a:pPr>
+            <a:r>
+              <a:t>Unix time uses seconds since 1970-01-01 00:00:00 UTC.</a:t>
             </a:r>
           </a:p>
           <a:p>
-            <a:r>
-              <a:rPr lang="en-GB" dirty="0"/>
-              <a:t>Mac OS epoch date is Midnight January 1, 2001, UTC</a:t>
+            <a:pPr>
+              <a:spcAft>
+                <a:spcPts val="600"/>
+              </a:spcAft>
+              <a:defRPr sz="2500"/>
+            </a:pPr>
+            <a:r>
+              <a:t>The offset is 978,307,200 seconds.</a:t>
             </a:r>
           </a:p>
           <a:p>
-            <a:pPr lvl="1"/>
-            <a:r>
-              <a:rPr lang="en-GB" dirty="0"/>
-              <a:t>Cocoa Core Data time is the number of </a:t>
-            </a:r>
-            <a:r>
-              <a:rPr lang="en-GB" dirty="0">
-                <a:solidFill>
-                  <a:srgbClr val="FF0000"/>
-                </a:solidFill>
-              </a:rPr>
-              <a:t>seconds</a:t>
-            </a:r>
-            <a:r>
-              <a:rPr lang="en-GB" dirty="0"/>
-              <a:t> elapsed since January 1, 2001, 00:00:00 UTC,</a:t>
-            </a:r>
-          </a:p>
-          <a:p>
-            <a:r>
-              <a:rPr lang="en-US" dirty="0">
-                <a:solidFill>
-                  <a:srgbClr val="232629"/>
-                </a:solidFill>
-                <a:latin typeface="-apple-system"/>
-              </a:rPr>
-              <a:t>Different is </a:t>
-            </a:r>
-            <a:r>
-              <a:rPr lang="en-US" b="0" i="0" dirty="0">
-                <a:solidFill>
-                  <a:srgbClr val="232629"/>
-                </a:solidFill>
-                <a:effectLst/>
-                <a:latin typeface="-apple-system"/>
-              </a:rPr>
-              <a:t>31 years (978,307,200 seconds) </a:t>
-            </a:r>
-          </a:p>
-          <a:p>
-            <a:r>
-              <a:rPr lang="en-US" dirty="0"/>
-              <a:t>Example: </a:t>
-            </a:r>
-            <a:r>
-              <a:rPr lang="en-US" dirty="0">
-                <a:solidFill>
-                  <a:srgbClr val="FF0000"/>
-                </a:solidFill>
-              </a:rPr>
-              <a:t>0,7</a:t>
-            </a:r>
-            <a:r>
-              <a:rPr lang="en-US" dirty="0"/>
-              <a:t>00,000,000 (</a:t>
-            </a:r>
-            <a:r>
-              <a:rPr lang="en-US"/>
-              <a:t>0.7 billion</a:t>
-            </a:r>
-            <a:r>
-              <a:rPr lang="en-US" dirty="0"/>
-              <a:t>)</a:t>
+            <a:pPr>
+              <a:spcAft>
+                <a:spcPts val="600"/>
+              </a:spcAft>
+              <a:defRPr sz="2500"/>
+            </a:pPr>
+            <a:r>
+              <a:t>Convert by adding or subtracting this offset before interpreting the timestamp.</a:t>
             </a:r>
           </a:p>
         </p:txBody>
@@ -22283,43 +22210,32 @@
       </p:pic>
       <p:sp>
         <p:nvSpPr>
-          <p:cNvPr id="10" name="TextBox 9">
-            <a:extLst>
-              <a:ext uri="{FF2B5EF4-FFF2-40B4-BE49-F238E27FC236}">
-                <a16:creationId xmlns:a16="http://schemas.microsoft.com/office/drawing/2014/main" id="{4661C3B4-1551-0A39-C984-122598124799}"/>
-              </a:ext>
-            </a:extLst>
-          </p:cNvPr>
+          <p:cNvPr id="11" name="TextBox 10"/>
           <p:cNvSpPr txBox="1"/>
           <p:nvPr/>
         </p:nvSpPr>
         <p:spPr>
           <a:xfrm>
-            <a:off x="978212" y="826394"/>
-            <a:ext cx="7308667" cy="369332"/>
+            <a:off x="731520" y="320040"/>
+            <a:ext cx="10698480" cy="502920"/>
           </a:xfrm>
           <a:prstGeom prst="rect">
             <a:avLst/>
           </a:prstGeom>
-          <a:solidFill>
-            <a:schemeClr val="accent4"/>
-          </a:solidFill>
+          <a:noFill/>
         </p:spPr>
         <p:txBody>
-          <a:bodyPr wrap="none" rtlCol="0">
+          <a:bodyPr wrap="none">
             <a:spAutoFit/>
           </a:bodyPr>
           <a:lstStyle/>
           <a:p>
-            <a:r>
-              <a:rPr lang="en-US" dirty="0"/>
-              <a:t>Write a function to compute the difference between Unix time and </a:t>
-            </a:r>
-            <a:r>
-              <a:rPr lang="en-US"/>
-              <a:t>iOS time</a:t>
-            </a:r>
-            <a:endParaRPr lang="en-US" dirty="0"/>
+            <a:pPr algn="l">
+              <a:defRPr sz="3400" b="0"/>
+            </a:pPr>
+            <a:r>
+              <a:t>Compute the Unix–Cocoa/Core Data Offset</a:t>
+            </a:r>
           </a:p>
         </p:txBody>
       </p:sp>
@@ -22374,13 +22290,11 @@
           <a:bodyPr/>
           <a:lstStyle/>
           <a:p>
-            <a:r>
-              <a:rPr lang="en-US" dirty="0" err="1"/>
-              <a:t>WebKit</a:t>
-            </a:r>
-            <a:r>
-              <a:rPr lang="en-US" dirty="0"/>
-              <a:t> time </a:t>
+            <a:pPr algn="l">
+              <a:defRPr sz="3600" b="0"/>
+            </a:pPr>
+            <a:r>
+              <a:t>WebKit / Chrome Time</a:t>
             </a:r>
           </a:p>
         </p:txBody>
@@ -22406,81 +22320,47 @@
           <a:bodyPr/>
           <a:lstStyle/>
           <a:p>
-            <a:r>
-              <a:rPr lang="en-GB" dirty="0"/>
-              <a:t>WebKit (Chrome) is a popular open-source rendering engine used by many web browsers</a:t>
+            <a:pPr>
+              <a:spcAft>
+                <a:spcPts val="600"/>
+              </a:spcAft>
+              <a:defRPr sz="2400"/>
+            </a:pPr>
+            <a:r>
+              <a:t>WebKit/Chrome timestamps are common in browser artifacts.</a:t>
             </a:r>
           </a:p>
           <a:p>
-            <a:pPr lvl="1"/>
-            <a:r>
-              <a:rPr lang="en-GB" dirty="0"/>
-              <a:t>Safari and Google Chrome.</a:t>
-            </a:r>
-            <a:endParaRPr lang="en-US" dirty="0"/>
+            <a:pPr>
+              <a:spcAft>
+                <a:spcPts val="600"/>
+              </a:spcAft>
+              <a:defRPr sz="2400"/>
+            </a:pPr>
+            <a:r>
+              <a:t>They are stored as microseconds since 1601-01-01 00:00:00 UTC.</a:t>
+            </a:r>
           </a:p>
           <a:p>
-            <a:r>
-              <a:rPr lang="en-GB" dirty="0"/>
-              <a:t>The time it takes for the </a:t>
-            </a:r>
-            <a:r>
-              <a:rPr lang="en-GB" dirty="0" err="1"/>
-              <a:t>WebKit</a:t>
-            </a:r>
-            <a:r>
-              <a:rPr lang="en-GB" dirty="0"/>
-              <a:t> rendering engine to render and display a webpage. </a:t>
+            <a:pPr>
+              <a:spcAft>
+                <a:spcPts val="600"/>
+              </a:spcAft>
+              <a:defRPr sz="2400"/>
+            </a:pPr>
+            <a:r>
+              <a:t>To convert to Unix seconds: adjust from the 1601 epoch, then divide by 1,000,000.</a:t>
             </a:r>
           </a:p>
           <a:p>
-            <a:r>
-              <a:rPr lang="en-GB" dirty="0" err="1"/>
-              <a:t>webkit</a:t>
-            </a:r>
-            <a:r>
-              <a:rPr lang="en-GB" dirty="0"/>
-              <a:t> </a:t>
-            </a:r>
-            <a:r>
-              <a:rPr lang="en-GB" dirty="0">
-                <a:solidFill>
-                  <a:srgbClr val="FF0000"/>
-                </a:solidFill>
-              </a:rPr>
-              <a:t>microsecond</a:t>
-            </a:r>
-            <a:r>
-              <a:rPr lang="en-GB" dirty="0"/>
-              <a:t> since 01/01/1601</a:t>
-            </a:r>
-          </a:p>
-          <a:p>
-            <a:r>
-              <a:rPr lang="en-GB" dirty="0"/>
-              <a:t>Example: </a:t>
-            </a:r>
-            <a:r>
-              <a:rPr lang="en-GB" dirty="0">
-                <a:solidFill>
-                  <a:srgbClr val="FF0000"/>
-                </a:solidFill>
-              </a:rPr>
-              <a:t>13</a:t>
-            </a:r>
-            <a:r>
-              <a:rPr lang="en-GB" dirty="0"/>
-              <a:t>,402,068,765, </a:t>
-            </a:r>
-            <a:r>
-              <a:rPr lang="en-GB" dirty="0">
-                <a:solidFill>
-                  <a:schemeClr val="bg2">
-                    <a:lumMod val="90000"/>
-                  </a:schemeClr>
-                </a:solidFill>
-              </a:rPr>
-              <a:t>000,000</a:t>
+            <a:pPr>
+              <a:spcAft>
+                <a:spcPts val="600"/>
+              </a:spcAft>
+              <a:defRPr sz="2400"/>
+            </a:pPr>
+            <a:r>
+              <a:t>Do not confuse this timestamp format with webpage rendering time.</a:t>
             </a:r>
           </a:p>
         </p:txBody>
@@ -22536,17 +22416,11 @@
           <a:bodyPr/>
           <a:lstStyle/>
           <a:p>
-            <a:r>
-              <a:rPr lang="en-US" dirty="0"/>
-              <a:t>H</a:t>
-            </a:r>
-            <a:r>
-              <a:rPr lang="en-US"/>
-              <a:t>ash </a:t>
-            </a:r>
-            <a:r>
-              <a:rPr lang="en-US" dirty="0"/>
-              <a:t>code</a:t>
+            <a:pPr algn="l">
+              <a:defRPr sz="4400" b="0"/>
+            </a:pPr>
+            <a:r>
+              <a:t>Hash Functions</a:t>
             </a:r>
           </a:p>
         </p:txBody>
@@ -22572,7 +22446,47 @@
           <a:bodyPr/>
           <a:lstStyle/>
           <a:p>
-            <a:endParaRPr lang="en-US"/>
+            <a:r>
+              <a:rPr lang="en-GB" dirty="0"/>
+              <a:t>Evidence integrity depends on hashing exact bytes</a:t>
+            </a:r>
+            <a:endParaRPr lang="en-US" dirty="0"/>
+          </a:p>
+        </p:txBody>
+      </p:sp>
+      <p:sp>
+        <p:nvSpPr>
+          <p:cNvPr id="4" name="TextBox 3"/>
+          <p:cNvSpPr txBox="1"/>
+          <p:nvPr/>
+        </p:nvSpPr>
+        <p:spPr>
+          <a:xfrm>
+            <a:off x="822960" y="4572000"/>
+            <a:ext cx="248786" cy="400110"/>
+          </a:xfrm>
+          <a:prstGeom prst="rect">
+            <a:avLst/>
+          </a:prstGeom>
+          <a:noFill/>
+        </p:spPr>
+        <p:txBody>
+          <a:bodyPr wrap="none">
+            <a:spAutoFit/>
+          </a:bodyPr>
+          <a:lstStyle/>
+          <a:p>
+            <a:pPr algn="l">
+              <a:defRPr sz="2000">
+                <a:solidFill>
+                  <a:srgbClr val="787878"/>
+                </a:solidFill>
+              </a:defRPr>
+            </a:pPr>
+            <a:r>
+              <a:rPr dirty="0"/>
+              <a:t>.</a:t>
+            </a:r>
           </a:p>
         </p:txBody>
       </p:sp>
@@ -22627,9 +22541,11 @@
           <a:bodyPr/>
           <a:lstStyle/>
           <a:p>
-            <a:r>
-              <a:rPr lang="en-US" dirty="0"/>
-              <a:t>Linux commands</a:t>
+            <a:pPr algn="l">
+              <a:defRPr sz="3600" b="0"/>
+            </a:pPr>
+            <a:r>
+              <a:t>Hashing Strings in Linux</a:t>
             </a:r>
           </a:p>
         </p:txBody>
@@ -22734,7 +22650,7 @@
             </a:r>
             <a:r>
               <a:rPr lang="en-GB" dirty="0" err="1"/>
-              <a:t>linebreak</a:t>
+              <a:t>line break</a:t>
             </a:r>
             <a:endParaRPr lang="en-US" dirty="0"/>
           </a:p>
@@ -22791,9 +22707,11 @@
           <a:bodyPr/>
           <a:lstStyle/>
           <a:p>
-            <a:r>
-              <a:rPr lang="en-US" dirty="0"/>
-              <a:t>Python</a:t>
+            <a:pPr algn="l">
+              <a:defRPr sz="3600" b="0"/>
+            </a:pPr>
+            <a:r>
+              <a:t>Hashing Strings in Python</a:t>
             </a:r>
           </a:p>
         </p:txBody>
@@ -22879,9 +22797,11 @@
           <a:bodyPr/>
           <a:lstStyle/>
           <a:p>
-            <a:r>
-              <a:rPr lang="en-US" dirty="0"/>
-              <a:t>Data stored in memory </a:t>
+            <a:pPr algn="l">
+              <a:defRPr sz="4400" b="0"/>
+            </a:pPr>
+            <a:r>
+              <a:t>Data Stored in Memory</a:t>
             </a:r>
           </a:p>
         </p:txBody>
@@ -22962,8 +22882,10 @@
           <a:bodyPr/>
           <a:lstStyle/>
           <a:p>
-            <a:r>
-              <a:rPr lang="en-US" dirty="0"/>
+            <a:pPr algn="l">
+              <a:defRPr sz="3600" b="0"/>
+            </a:pPr>
+            <a:r>
               <a:t>Endianness</a:t>
             </a:r>
           </a:p>
@@ -22990,52 +22912,48 @@
           <a:bodyPr/>
           <a:lstStyle/>
           <a:p>
-            <a:r>
-              <a:rPr lang="en-GB" dirty="0"/>
-              <a:t>Endianness is a term that describe the order in which a sequence of bytes (byte order) is stored in </a:t>
-            </a:r>
-            <a:r>
-              <a:rPr lang="en-GB" dirty="0">
-                <a:solidFill>
-                  <a:srgbClr val="FF0000"/>
-                </a:solidFill>
-              </a:rPr>
-              <a:t>memory</a:t>
-            </a:r>
-            <a:r>
-              <a:rPr lang="en-GB" dirty="0"/>
-              <a:t>. </a:t>
+            <a:pPr>
+              <a:spcAft>
+                <a:spcPts val="600"/>
+              </a:spcAft>
+              <a:defRPr sz="2500"/>
+            </a:pPr>
+            <a:r>
+              <a:t>Endianness describes byte order for multi-byte values.</a:t>
             </a:r>
           </a:p>
           <a:p>
-            <a:r>
-              <a:rPr lang="en-GB" dirty="0"/>
-              <a:t>Little-endian </a:t>
+            <a:pPr>
+              <a:spcAft>
+                <a:spcPts val="600"/>
+              </a:spcAft>
+              <a:defRPr sz="2500"/>
+            </a:pPr>
+            <a:r>
+              <a:t>Little-endian stores the least-significant byte first at the lowest address.</a:t>
             </a:r>
           </a:p>
           <a:p>
-            <a:pPr lvl="1"/>
-            <a:r>
-              <a:rPr lang="en-GB" dirty="0"/>
-              <a:t>is an order in which the "little end" (least significant value in the sequence) is stored first.</a:t>
+            <a:pPr>
+              <a:spcAft>
+                <a:spcPts val="600"/>
+              </a:spcAft>
+              <a:defRPr sz="2500"/>
+            </a:pPr>
+            <a:r>
+              <a:t>Big-endian stores the most-significant byte first at the lowest address.</a:t>
             </a:r>
           </a:p>
           <a:p>
-            <a:r>
-              <a:rPr lang="en-GB" dirty="0"/>
-              <a:t>Big-endian </a:t>
-            </a:r>
-          </a:p>
-          <a:p>
-            <a:pPr lvl="1"/>
-            <a:r>
-              <a:rPr lang="en-GB" dirty="0"/>
-              <a:t>is an order in which the "big end" (most significant value in the sequence) is stored first (at the lowest storage address). </a:t>
-            </a:r>
-          </a:p>
-          <a:p>
-            <a:pPr lvl="1"/>
-            <a:endParaRPr lang="en-US" dirty="0"/>
+            <a:pPr>
+              <a:spcAft>
+                <a:spcPts val="600"/>
+              </a:spcAft>
+              <a:defRPr sz="2500"/>
+            </a:pPr>
+            <a:r>
+              <a:t>Forensics: wrong byte order can produce the wrong value or timestamp.</a:t>
+            </a:r>
           </a:p>
         </p:txBody>
       </p:sp>
@@ -23221,7 +23139,7 @@
                   <a:srgbClr val="7030A0"/>
                 </a:solidFill>
               </a:rPr>
-              <a:t>Least significant value</a:t>
+              <a:t>least-significant byte</a:t>
             </a:r>
           </a:p>
         </p:txBody>
@@ -23697,6 +23615,38 @@
           </mc:Fallback>
         </mc:AlternateContent>
       </p:grpSp>
+      <p:sp>
+        <p:nvSpPr>
+          <p:cNvPr id="19" name="TextBox 18"/>
+          <p:cNvSpPr txBox="1"/>
+          <p:nvPr/>
+        </p:nvSpPr>
+        <p:spPr>
+          <a:xfrm>
+            <a:off x="731520" y="320040"/>
+            <a:ext cx="10698480" cy="502920"/>
+          </a:xfrm>
+          <a:prstGeom prst="rect">
+            <a:avLst/>
+          </a:prstGeom>
+          <a:noFill/>
+        </p:spPr>
+        <p:txBody>
+          <a:bodyPr wrap="none">
+            <a:spAutoFit/>
+          </a:bodyPr>
+          <a:lstStyle/>
+          <a:p>
+            <a:pPr>
+              <a:defRPr sz="3200" b="0"/>
+            </a:pPr>
+            <a:r>
+              <a:rPr dirty="0"/>
+              <a:t>Little-Endian vs. Big-Endian</a:t>
+            </a:r>
+          </a:p>
+        </p:txBody>
+      </p:sp>
     </p:spTree>
     <p:extLst>
       <p:ext uri="{BB962C8B-B14F-4D97-AF65-F5344CB8AC3E}">
@@ -23750,13 +23700,13 @@
           <p:nvPr>
             <p:extLst>
               <p:ext uri="{D42A27DB-BD31-4B8C-83A1-F6EECF244321}">
-                <p14:modId xmlns:p14="http://schemas.microsoft.com/office/powerpoint/2010/main" val="4192335178"/>
+                <p14:modId xmlns:p14="http://schemas.microsoft.com/office/powerpoint/2010/main" val="3843767379"/>
               </p:ext>
             </p:extLst>
           </p:nvPr>
         </p:nvGraphicFramePr>
         <p:xfrm>
-          <a:off x="1009312" y="2719773"/>
+          <a:off x="861828" y="3221219"/>
           <a:ext cx="9925373" cy="2754080"/>
         </p:xfrm>
         <a:graphic>
@@ -28614,7 +28564,7 @@
         </p:blipFill>
         <p:spPr>
           <a:xfrm>
-            <a:off x="5327002" y="1082695"/>
+            <a:off x="5179518" y="1584141"/>
             <a:ext cx="2855666" cy="1219538"/>
           </a:xfrm>
           <a:prstGeom prst="rect">
@@ -28637,7 +28587,7 @@
           <p:nvPr/>
         </p:nvPicPr>
         <p:blipFill>
-          <a:blip r:embed="rId3">
+          <a:blip r:embed="rId3" cstate="print">
             <a:extLst>
               <a:ext uri="{28A0092B-C50C-407E-A947-70E740481C1C}">
                 <a14:useLocalDpi xmlns:a14="http://schemas.microsoft.com/office/drawing/2010/main" val="0"/>
@@ -28651,7 +28601,7 @@
         </p:blipFill>
         <p:spPr bwMode="auto">
           <a:xfrm>
-            <a:off x="1851491" y="1169132"/>
+            <a:off x="1704007" y="1670578"/>
             <a:ext cx="2635354" cy="1046665"/>
           </a:xfrm>
           <a:prstGeom prst="rect">
@@ -28686,7 +28636,7 @@
         </p:nvCxnSpPr>
         <p:spPr>
           <a:xfrm flipH="1" flipV="1">
-            <a:off x="3169168" y="2215797"/>
+            <a:off x="3021684" y="2717243"/>
             <a:ext cx="2426350" cy="1449174"/>
           </a:xfrm>
           <a:prstGeom prst="straightConnector1">
@@ -28727,7 +28677,7 @@
         </p:nvCxnSpPr>
         <p:spPr>
           <a:xfrm flipH="1" flipV="1">
-            <a:off x="6913196" y="2215797"/>
+            <a:off x="6765712" y="2717243"/>
             <a:ext cx="270616" cy="1999364"/>
           </a:xfrm>
           <a:prstGeom prst="straightConnector1">
@@ -28773,7 +28723,7 @@
         </p:blipFill>
         <p:spPr>
           <a:xfrm>
-            <a:off x="8990516" y="1006259"/>
+            <a:off x="8843032" y="1507705"/>
             <a:ext cx="1320258" cy="1276805"/>
           </a:xfrm>
           <a:prstGeom prst="rect">
@@ -28797,7 +28747,7 @@
         </p:nvCxnSpPr>
         <p:spPr>
           <a:xfrm flipV="1">
-            <a:off x="9500346" y="2121570"/>
+            <a:off x="9352862" y="2623016"/>
             <a:ext cx="182188" cy="2450052"/>
           </a:xfrm>
           <a:prstGeom prst="straightConnector1">
@@ -28822,8 +28772,8 @@
           </a:fontRef>
         </p:style>
       </p:cxnSp>
-      <mc:AlternateContent xmlns:mc="http://schemas.openxmlformats.org/markup-compatibility/2006" xmlns:p14="http://schemas.microsoft.com/office/powerpoint/2010/main">
-        <mc:Choice Requires="p14">
+      <mc:AlternateContent xmlns:mc="http://schemas.openxmlformats.org/markup-compatibility/2006">
+        <mc:Choice xmlns:p14="http://schemas.microsoft.com/office/powerpoint/2010/main" Requires="p14">
           <p:contentPart p14:bwMode="auto" r:id="rId5">
             <p14:nvContentPartPr>
               <p14:cNvPr id="25" name="Ink 24">
@@ -28837,12 +28787,12 @@
               <p14:nvPr/>
             </p14:nvContentPartPr>
             <p14:xfrm>
-              <a:off x="9017365" y="4631447"/>
+              <a:off x="8869881" y="5132893"/>
               <a:ext cx="360" cy="360"/>
             </p14:xfrm>
           </p:contentPart>
         </mc:Choice>
-        <mc:Fallback xmlns="">
+        <mc:Fallback>
           <p:pic>
             <p:nvPicPr>
               <p:cNvPr id="25" name="Ink 24">
@@ -28863,7 +28813,7 @@
             </p:blipFill>
             <p:spPr>
               <a:xfrm>
-                <a:off x="9008365" y="4622447"/>
+                <a:off x="8860881" y="5123893"/>
                 <a:ext cx="18000" cy="18000"/>
               </a:xfrm>
               <a:prstGeom prst="rect">
@@ -28873,8 +28823,8 @@
           </p:pic>
         </mc:Fallback>
       </mc:AlternateContent>
-      <mc:AlternateContent xmlns:mc="http://schemas.openxmlformats.org/markup-compatibility/2006" xmlns:p14="http://schemas.microsoft.com/office/powerpoint/2010/main">
-        <mc:Choice Requires="p14">
+      <mc:AlternateContent xmlns:mc="http://schemas.openxmlformats.org/markup-compatibility/2006">
+        <mc:Choice xmlns:p14="http://schemas.microsoft.com/office/powerpoint/2010/main" Requires="p14">
           <p:contentPart p14:bwMode="auto" r:id="rId7">
             <p14:nvContentPartPr>
               <p14:cNvPr id="26" name="Ink 25">
@@ -28888,12 +28838,12 @@
               <p14:nvPr/>
             </p14:nvContentPartPr>
             <p14:xfrm>
-              <a:off x="11210485" y="4809647"/>
+              <a:off x="11063001" y="5311093"/>
               <a:ext cx="360" cy="360"/>
             </p14:xfrm>
           </p:contentPart>
         </mc:Choice>
-        <mc:Fallback xmlns="">
+        <mc:Fallback>
           <p:pic>
             <p:nvPicPr>
               <p:cNvPr id="26" name="Ink 25">
@@ -28914,7 +28864,7 @@
             </p:blipFill>
             <p:spPr>
               <a:xfrm>
-                <a:off x="11201485" y="4800647"/>
+                <a:off x="11054001" y="5302093"/>
                 <a:ext cx="18000" cy="18000"/>
               </a:xfrm>
               <a:prstGeom prst="rect">
@@ -28924,6 +28874,34 @@
           </p:pic>
         </mc:Fallback>
       </mc:AlternateContent>
+      <p:sp>
+        <p:nvSpPr>
+          <p:cNvPr id="2" name="Title 1">
+            <a:extLst>
+              <a:ext uri="{FF2B5EF4-FFF2-40B4-BE49-F238E27FC236}">
+                <a16:creationId xmlns:a16="http://schemas.microsoft.com/office/drawing/2014/main" id="{B49DB046-1860-08BD-8256-2D8A2463869C}"/>
+              </a:ext>
+            </a:extLst>
+          </p:cNvPr>
+          <p:cNvSpPr>
+            <a:spLocks noGrp="1"/>
+          </p:cNvSpPr>
+          <p:nvPr>
+            <p:ph type="title"/>
+          </p:nvPr>
+        </p:nvSpPr>
+        <p:spPr/>
+        <p:txBody>
+          <a:bodyPr/>
+          <a:lstStyle/>
+          <a:p>
+            <a:r>
+              <a:rPr lang="en-US" dirty="0"/>
+              <a:t>Number Systems in Digital Forensics</a:t>
+            </a:r>
+          </a:p>
+        </p:txBody>
+      </p:sp>
     </p:spTree>
     <p:extLst>
       <p:ext uri="{BB962C8B-B14F-4D97-AF65-F5344CB8AC3E}">
@@ -29016,8 +28994,45 @@
           <a:p>
             <a:r>
               <a:rPr lang="en-US" dirty="0"/>
-              <a:t>Check Byte order</a:t>
-            </a:r>
+              <a:t>Check byte order</a:t>
+            </a:r>
+          </a:p>
+        </p:txBody>
+      </p:sp>
+      <p:sp>
+        <p:nvSpPr>
+          <p:cNvPr id="5" name="TextBox 4"/>
+          <p:cNvSpPr txBox="1"/>
+          <p:nvPr/>
+        </p:nvSpPr>
+        <p:spPr>
+          <a:xfrm>
+            <a:off x="731520" y="320040"/>
+            <a:ext cx="10698480" cy="502920"/>
+          </a:xfrm>
+          <a:prstGeom prst="rect">
+            <a:avLst/>
+          </a:prstGeom>
+          <a:noFill/>
+        </p:spPr>
+        <p:txBody>
+          <a:bodyPr wrap="none">
+            <a:spAutoFit/>
+          </a:bodyPr>
+          <a:lstStyle/>
+          <a:p>
+            <a:pPr>
+              <a:defRPr sz="3200" b="0"/>
+            </a:pPr>
+            <a:r>
+              <a:rPr dirty="0"/>
+              <a:t>Check Byte Order with </a:t>
+            </a:r>
+            <a:r>
+              <a:rPr dirty="0" err="1"/>
+              <a:t>lscpu</a:t>
+            </a:r>
+            <a:endParaRPr dirty="0"/>
           </a:p>
         </p:txBody>
       </p:sp>
@@ -29027,6 +29042,103 @@
         <p14:creationId xmlns:p14="http://schemas.microsoft.com/office/powerpoint/2010/main" val="1515556541"/>
       </p:ext>
     </p:extLst>
+  </p:cSld>
+  <p:clrMapOvr>
+    <a:masterClrMapping/>
+  </p:clrMapOvr>
+</p:sld>
+</file>
+
+<file path=ppt/slides/slide41.xml><?xml version="1.0" encoding="utf-8"?>
+<p:sld xmlns:a="http://schemas.openxmlformats.org/drawingml/2006/main" xmlns:r="http://schemas.openxmlformats.org/officeDocument/2006/relationships" xmlns:p="http://schemas.openxmlformats.org/presentationml/2006/main">
+  <p:cSld>
+    <p:spTree>
+      <p:nvGrpSpPr>
+        <p:cNvPr id="1" name=""/>
+        <p:cNvGrpSpPr/>
+        <p:nvPr/>
+      </p:nvGrpSpPr>
+      <p:grpSpPr>
+        <a:xfrm>
+          <a:off x="0" y="0"/>
+          <a:ext cx="0" cy="0"/>
+          <a:chOff x="0" y="0"/>
+          <a:chExt cx="0" cy="0"/>
+        </a:xfrm>
+      </p:grpSpPr>
+      <p:sp>
+        <p:nvSpPr>
+          <p:cNvPr id="2" name="Title 1"/>
+          <p:cNvSpPr>
+            <a:spLocks noGrp="1"/>
+          </p:cNvSpPr>
+          <p:nvPr>
+            <p:ph type="title"/>
+          </p:nvPr>
+        </p:nvSpPr>
+        <p:spPr/>
+        <p:txBody>
+          <a:bodyPr/>
+          <a:lstStyle/>
+          <a:p>
+            <a:r>
+              <a:rPr lang="en-GB" dirty="0"/>
+              <a:t>Key Takeaways for Digital Forensics</a:t>
+            </a:r>
+            <a:endParaRPr dirty="0"/>
+          </a:p>
+        </p:txBody>
+      </p:sp>
+      <p:sp>
+        <p:nvSpPr>
+          <p:cNvPr id="3" name="Content Placeholder 2"/>
+          <p:cNvSpPr>
+            <a:spLocks noGrp="1"/>
+          </p:cNvSpPr>
+          <p:nvPr>
+            <p:ph idx="1"/>
+          </p:nvPr>
+        </p:nvSpPr>
+        <p:spPr/>
+        <p:txBody>
+          <a:bodyPr/>
+          <a:lstStyle/>
+          <a:p>
+            <a:r>
+              <a:rPr lang="en-GB" dirty="0"/>
+              <a:t>Binary and hexadecimal help examiners read raw bytes.</a:t>
+            </a:r>
+          </a:p>
+          <a:p>
+            <a:r>
+              <a:rPr lang="en-GB" dirty="0"/>
+              <a:t>ASCII and Unicode determine how bytes become readable text.</a:t>
+            </a:r>
+          </a:p>
+          <a:p>
+            <a:r>
+              <a:rPr lang="en-GB" dirty="0"/>
+              <a:t>Timestamps require the correct epoch, unit, and time zone.</a:t>
+            </a:r>
+          </a:p>
+          <a:p>
+            <a:r>
+              <a:rPr lang="en-GB" dirty="0"/>
+              <a:t>Endianness controls how multi-byte values are reconstructed from memory.</a:t>
+            </a:r>
+          </a:p>
+          <a:p>
+            <a:r>
+              <a:rPr lang="en-GB" dirty="0"/>
+              <a:t>Hashes verify that evidence bytes have not changed.</a:t>
+            </a:r>
+          </a:p>
+          <a:p>
+            <a:endParaRPr dirty="0"/>
+          </a:p>
+        </p:txBody>
+      </p:sp>
+    </p:spTree>
   </p:cSld>
   <p:clrMapOvr>
     <a:masterClrMapping/>
@@ -29072,13 +29184,12 @@
           <a:bodyPr/>
           <a:lstStyle/>
           <a:p>
-            <a:r>
-              <a:rPr lang="en-US" dirty="0"/>
-              <a:t>Conversion among </a:t>
-            </a:r>
-            <a:r>
-              <a:rPr lang="en-US" sz="4400" dirty="0"/>
-              <a:t>number systems</a:t>
+            <a:pPr algn="l">
+              <a:defRPr sz="3600" b="0"/>
+            </a:pPr>
+            <a:r>
+              <a:rPr dirty="0"/>
+              <a:t>Converting Between Decimal, Binary, and Hexadecimal</a:t>
             </a:r>
             <a:endParaRPr lang="en-US" dirty="0"/>
           </a:p>
@@ -29464,9 +29575,12 @@
           <a:bodyPr/>
           <a:lstStyle/>
           <a:p>
-            <a:r>
-              <a:rPr lang="en-US" dirty="0"/>
-              <a:t>Conversion table</a:t>
+            <a:pPr algn="l">
+              <a:defRPr sz="3600" b="0"/>
+            </a:pPr>
+            <a:r>
+              <a:rPr dirty="0"/>
+              <a:t>Decimal, Binary, and Hexadecimal Values</a:t>
             </a:r>
           </a:p>
         </p:txBody>
@@ -40906,9 +41020,12 @@
           <a:bodyPr/>
           <a:lstStyle/>
           <a:p>
-            <a:r>
-              <a:rPr lang="en-US" dirty="0"/>
-              <a:t>Binary Addition </a:t>
+            <a:pPr algn="l">
+              <a:defRPr sz="3600" b="0"/>
+            </a:pPr>
+            <a:r>
+              <a:rPr dirty="0"/>
+              <a:t>Binary Addition: Carry Bits</a:t>
             </a:r>
           </a:p>
         </p:txBody>
@@ -44518,9 +44635,12 @@
           <a:bodyPr/>
           <a:lstStyle/>
           <a:p>
-            <a:r>
-              <a:rPr lang="en-US" altLang="en-US" dirty="0"/>
-              <a:t>Decimal to Decimal</a:t>
+            <a:pPr algn="l">
+              <a:defRPr sz="3600" b="0"/>
+            </a:pPr>
+            <a:r>
+              <a:rPr dirty="0"/>
+              <a:t>Decimal Place Value</a:t>
             </a:r>
             <a:endParaRPr lang="en-US" dirty="0"/>
           </a:p>
@@ -44935,7 +45055,7 @@
             <a:pPr algn="ctr"/>
             <a:r>
               <a:rPr lang="en-US" altLang="en-US"/>
-              <a:t>Weight</a:t>
+              <a:t>place weight</a:t>
             </a:r>
           </a:p>
         </p:txBody>
@@ -44986,7 +45106,7 @@
             <a:pPr algn="ctr"/>
             <a:r>
               <a:rPr lang="en-US" altLang="en-US" dirty="0"/>
-              <a:t>placeholder</a:t>
+              <a:t>digit</a:t>
             </a:r>
           </a:p>
         </p:txBody>
@@ -45265,8 +45385,10 @@
           <a:bodyPr/>
           <a:lstStyle/>
           <a:p>
-            <a:r>
-              <a:rPr lang="en-US" dirty="0"/>
+            <a:pPr algn="l">
+              <a:defRPr sz="3600" b="0"/>
+            </a:pPr>
+            <a:r>
               <a:t>Binary to Decimal</a:t>
             </a:r>
           </a:p>
@@ -45298,53 +45420,52 @@
           <a:bodyPr/>
           <a:lstStyle/>
           <a:p>
-            <a:r>
-              <a:rPr lang="en-US" altLang="en-US" dirty="0"/>
-              <a:t>Multiply each bit by </a:t>
-            </a:r>
-            <a:r>
-              <a:rPr lang="en-US" altLang="en-US" dirty="0">
-                <a:solidFill>
-                  <a:srgbClr val="C00000"/>
-                </a:solidFill>
-              </a:rPr>
-              <a:t>2</a:t>
-            </a:r>
-            <a:r>
-              <a:rPr lang="en-US" altLang="en-US" sz="3300" i="1" baseline="30000" dirty="0">
-                <a:solidFill>
-                  <a:srgbClr val="C00000"/>
-                </a:solidFill>
-              </a:rPr>
-              <a:t>n</a:t>
-            </a:r>
-            <a:r>
-              <a:rPr lang="en-US" altLang="en-US" dirty="0"/>
-              <a:t>, where </a:t>
-            </a:r>
-            <a:r>
-              <a:rPr lang="en-US" altLang="en-US" i="1" dirty="0"/>
-              <a:t>n</a:t>
-            </a:r>
-            <a:r>
-              <a:rPr lang="en-US" altLang="en-US" dirty="0"/>
-              <a:t> is the “weight” of the bit</a:t>
+            <a:pPr>
+              <a:spcAft>
+                <a:spcPts val="600"/>
+              </a:spcAft>
+              <a:defRPr sz="2400"/>
+            </a:pPr>
+            <a:r>
+              <a:rPr dirty="0"/>
+              <a:t>Each bit has a positional weight: 2ⁿ</a:t>
             </a:r>
           </a:p>
           <a:p>
-            <a:r>
-              <a:rPr lang="en-US" altLang="en-US" dirty="0"/>
-              <a:t>The weight is the position of the bit, starting from 0 on the right</a:t>
+            <a:pPr>
+              <a:spcAft>
+                <a:spcPts val="600"/>
+              </a:spcAft>
+              <a:defRPr sz="2400"/>
+            </a:pPr>
+            <a:r>
+              <a:rPr dirty="0"/>
+              <a:t>Count positions from the right, starting at 0</a:t>
             </a:r>
           </a:p>
           <a:p>
-            <a:r>
-              <a:rPr lang="en-US" altLang="en-US" dirty="0"/>
-              <a:t>Add the results</a:t>
+            <a:pPr>
+              <a:spcAft>
+                <a:spcPts val="600"/>
+              </a:spcAft>
+              <a:defRPr sz="2400"/>
+            </a:pPr>
+            <a:r>
+              <a:rPr dirty="0"/>
+              <a:t>Multiply each bit by its weight</a:t>
             </a:r>
           </a:p>
           <a:p>
-            <a:endParaRPr lang="en-US" dirty="0"/>
+            <a:pPr>
+              <a:spcAft>
+                <a:spcPts val="600"/>
+              </a:spcAft>
+              <a:defRPr sz="2400"/>
+            </a:pPr>
+            <a:r>
+              <a:rPr dirty="0"/>
+              <a:t>Add the products to get the decimal value</a:t>
+            </a:r>
           </a:p>
         </p:txBody>
       </p:sp>
@@ -45958,7 +46079,7 @@
             <a:pPr algn="ctr"/>
             <a:r>
               <a:rPr lang="en-US" altLang="en-US" dirty="0"/>
-              <a:t>placeholder</a:t>
+              <a:t>bit</a:t>
             </a:r>
           </a:p>
         </p:txBody>
@@ -46063,7 +46184,7 @@
             <a:pPr algn="ctr"/>
             <a:r>
               <a:rPr lang="en-US" altLang="en-US"/>
-              <a:t>Weight</a:t>
+              <a:t>weight</a:t>
             </a:r>
           </a:p>
         </p:txBody>

</xml_diff>

<commit_message>
update Ch1 and Ch2 presentations for Digital Forensics
</commit_message>
<xml_diff>
--- a/PPTs/Ch2_Number_Systems_for_Digital_Forensics.pptx
+++ b/PPTs/Ch2_Number_Systems_for_Digital_Forensics.pptx
@@ -786,7 +786,7 @@
       <inkml:brushProperty name="color" value="#FF0066"/>
     </inkml:brush>
   </inkml:definitions>
-  <inkml:trace contextRef="#ctx0" brushRef="#br0">1193 241 24575,'-1'-1'0,"1"0"0,0 0 0,-1 0 0,1 0 0,-1 1 0,1-1 0,-1 0 0,1 0 0,-1 1 0,0-1 0,1 0 0,-1 1 0,0-1 0,1 0 0,-1 1 0,0-1 0,0 1 0,0-1 0,1 1 0,-1 0 0,0-1 0,0 1 0,0 0 0,0 0 0,0-1 0,0 1 0,-1 0 0,-31-3 0,30 2 0,-28-1 0,0 1 0,0 2 0,0 1 0,-55 10 0,21-2 0,52-9 0,0 0 0,0 1 0,1 1 0,-1 0 0,-21 8 0,-29 12 0,49-19 0,0 0 0,1 1 0,-1 1 0,1 0 0,1 1 0,-16 10 0,21-13 0,-1 0 0,1 0 0,-1 0 0,0-1 0,0-1 0,-1 1 0,1-1 0,-1 0 0,1-1 0,-12 0 0,-21 6 0,18-3 0,1 1 0,0 2 0,0 0 0,0 1 0,1 1 0,-35 21 0,36-17 0,0 2 0,1 0 0,0 0 0,-31 37 0,-18 11 0,61-56 0,0 1 0,1 0 0,0 0 0,1 0 0,0 1 0,0-1 0,0 1 0,1 1 0,1-1 0,0 1 0,0-1 0,1 1 0,0 0 0,0 0 0,0 17 0,2-15 0,0 1 0,1-1 0,0 0 0,1 1 0,4 15 0,-5-24 0,1 1 0,0-1 0,0 0 0,0 0 0,1 0 0,-1 0 0,1 0 0,0-1 0,0 1 0,0-1 0,1 0 0,-1 0 0,1 0 0,0 0 0,-1-1 0,1 1 0,6 1 0,11 8 0,-1 1 0,0 1 0,32 28 0,0 1 0,-44-38 0,0 0 0,0-1 0,1 0 0,-1-1 0,10 3 0,26 12 0,170 113 0,-147-87 0,-35-26 0,56 24 0,-34-17 0,-13-8 0,61 17 0,32 14 0,-15-9 0,-95-30 0,-1-2 0,45 9 0,-18-6 0,-17-4 0,0-2 0,0-1 0,67-4 0,-40 0 0,-48 1 0,1-2 0,-1 0 0,15-3 0,28-5 0,-37 7 0,-1 0 0,1-1 0,-1-2 0,0 1 0,-1-2 0,1 0 0,-1-1 0,-1-1 0,21-14 0,-23 16 0,0 0 0,1 0 0,27-8 0,-29 12 0,-1-1 0,0 0 0,0-1 0,0 0 0,-1-1 0,0 0 0,16-13 0,15-23 0,-30 30 0,0 0 0,1 0 0,26-18 0,-26 20 0,-2 1 0,1-1 0,-1-1 0,-1 0 0,14-20 0,-14 19 0,0 0 0,-1-1 0,-1 0 0,0 0 0,0 0 0,-1-1 0,-1 0 0,0 0 0,-1-1 0,-1 1 0,0-1 0,-1 0 0,-1 0 0,0 0 0,-2-21 0,1-302 0,-1 322 0,-1 2 0,-6-28 0,-2-25 0,8 47 0,-1-1 0,0 1 0,-2 0 0,0 1 0,-2-1 0,0 1 0,-1 0 0,-1 1 0,0 0 0,-16-22 0,10 10 0,13 26 0,1 0 0,-1 1 0,0-1 0,1 0 0,-1 1 0,-1 0 0,1-1 0,-1 1 0,1 0 0,-1 0 0,0 0 0,0 1 0,0-1 0,0 1 0,-6-4 0,-24-11 0,0 2 0,-2 1 0,-40-12 0,57 22 0,6 2 0,0-1 0,0-1 0,0 0 0,-18-10 0,17 8 0,0 0 0,-1 1 0,0 0 0,0 1 0,0 0 0,-1 2 0,-23-3 0,-107 5 0,65 3 0,-495-3-1365,558 0-5461</inkml:trace>
+  <inkml:trace contextRef="#ctx0" brushRef="#br0">1216 246 24575,'-1'-1'0,"1"0"0,0 0 0,-1 0 0,1 0 0,-1 1 0,1-1 0,-1 0 0,1 0 0,-1 1 0,0-1 0,1-1 0,-1 2 0,0-1 0,1 0 0,-1 1 0,0-1 0,0 1 0,0-1 0,1 1 0,-1 0 0,0-1 0,0 1 0,0 0 0,0 0 0,0-1 0,0 1 0,-1 0 0,-32-3 0,31 2 0,-28-1 0,-1 1 0,0 2 0,1 1 0,-57 11 0,22-3 0,53-9 0,-1 0 0,1 1 0,1 1 0,-1 0 0,-22 8 0,-29 13 0,49-20 0,1 0 0,1 1 0,-1 1 0,0 0 0,2 1 0,-16 11 0,20-14 0,0 0 0,1 0 0,-1 0 0,0-1 0,0-1 0,-2 1 0,2-1 0,-1 0 0,1-1 0,-12 0 0,-22 6 0,18-3 0,2 1 0,-1 3 0,1-1 0,0 1 0,0 1 0,-35 22 0,37-18 0,-1 2 0,2 0 0,0 1 0,-32 37 0,-19 11 0,63-57 0,0 1 0,1 0 0,0 1 0,1-1 0,0 1 0,0-1 0,-1 1 0,2 1 0,1 0 0,0 0 0,0-1 0,1 1 0,0 0 0,0 1 0,0 16 0,2-15 0,0 2 0,1-2 0,0 0 0,1 1 0,4 16 0,-5-25 0,1 1 0,0-1 0,0 0 0,0 0 0,1 0 0,-1 0 0,2 1 0,-1-2 0,0 1 0,0-1 0,1 0 0,-1 0 0,1 0 0,0 0 0,-1-1 0,1 1 0,6 1 0,12 8 0,-2 2 0,1 0 0,32 29 0,0 1 0,-45-39 0,0 0 0,0-1 0,1 0 0,-1-1 0,11 3 0,26 12 0,173 116 0,-150-89 0,-35-27 0,56 25 0,-34-18 0,-13-7 0,62 16 0,33 15 0,-16-9 0,-96-31 0,-2-2 0,46 10 0,-18-7 0,-17-4 0,0-2 0,-1-1 0,69-4 0,-41 0 0,-48 1 0,0-2 0,-1 0 0,16-3 0,28-5 0,-38 7 0,-1 0 0,2-1 0,-2-3 0,0 2 0,0-2 0,0 0 0,-1-1 0,0-1 0,20-15 0,-22 17 0,-1 0 0,1 0 0,28-8 0,-30 12 0,-1-1 0,1-1 0,-1 0 0,0 0 0,-1-1 0,0 0 0,17-13 0,15-24 0,-31 31 0,0-1 0,1 1 0,27-18 0,-27 19 0,-1 2 0,0-1 0,-1-1 0,-1 0 0,15-21 0,-15 20 0,0-1 0,-1 0 0,-1 0 0,0 0 0,0-1 0,0 0 0,-2 0 0,0 0 0,-1-2 0,-1 2 0,0-1 0,-1-1 0,-1 1 0,0 0 0,-2-22 0,1-307 0,-1 327 0,-1 3 0,-6-29 0,-2-25 0,8 48 0,-1-2 0,-1 2 0,-1-1 0,0 2 0,-2-1 0,0 0 0,-1 1 0,-1 0 0,-1 1 0,-15-23 0,10 11 0,13 26 0,1 0 0,-1 1 0,0-2 0,1 1 0,-1 1 0,-2 0 0,2-1 0,-1 1 0,1 0 0,-1 0 0,0 0 0,0 1 0,0-1 0,0 1 0,-6-4 0,-25-12 0,1 3 0,-3 1 0,-41-13 0,59 23 0,6 2 0,0-1 0,-1-1 0,1 0 0,-18-10 0,16 8 0,1-1 0,-1 2 0,0 0 0,-1 1 0,1 0 0,-1 2 0,-24-3 0,-109 5 0,67 3 0,-506-3-1365,570 0-5461</inkml:trace>
 </inkml:ink>
 </file>
 
@@ -814,7 +814,7 @@
       <inkml:brushProperty name="color" value="#FF0066"/>
     </inkml:brush>
   </inkml:definitions>
-  <inkml:trace contextRef="#ctx0" brushRef="#br0">1 1 24575,'32'1'0,"0"2"0,34 8 0,-37-6 0,-22-3 0,1 1 0,-1 0 0,0 0 0,0 0 0,-1 1 0,1 0 0,-1 1 0,0-1 0,0 1 0,6 7 0,-3-4 0,-1-1 0,2 0 0,16 10 0,70 33 0,-55-26 0,0-3 0,78 28 0,-86-37 0,0 1 0,35 21 0,-40-19 0,0-1 0,1-2 0,37 12 0,-8-6 0,-1 3 0,63 32 0,-1 0 0,-101-47 0,1-1 0,1 0 0,31 3 0,-26-5 0,35 10 0,62 34 0,-18-5 0,-71-30 0,38 21 0,-45-19 0,1-2 0,47 15 0,63 20 0,-94-29 0,73 18 0,-86-27-198,1 1 1,-1 2-1,44 24 0,13 5 143,43 15-14,169 64-914,-231-97 771,87 25 902,22 3-1450,20 5 1332,42-11-1361,-151-28 789,109 7 0,-12-3 0,-15-7 0,-23-4 0,-56-2 0,-45-5 0,62 13 0,162 29-1272,-8 5 1272,251 42-1608,-319-60 1608,96 10 0,75-2 0,-268-22 0,-14-2 0,113 7 0,-55-14 0,53 2 0,169 20 0,-222-14 0,551 47 0,-536-51 0,74 8 0,43-5 264,-76-8 58,406 2-1179,-369-12 605,599 2 252,-636 10 0,-2 0 0,-22-8 0,285-5 0,-218-16-217,103-26 217,-137 14 0,-12-8 0,-60 10 0,-81 16 0,70-9 0,-54 12 212,71-20-1,16-3-1097,-64 17 733,122-15 547,-155 24-394,67-16 0,30-5 0,-92 18 0,-2-2 0,1-4 0,100-38 0,-21 5 172,24-9 523,-28 11 571,-8 3-518,128-59-499,-186 67-249,-45 22 0,45-17 0,-3 4 0,123-70 0,-72 34 0,-99 53 179,1-2 0,-2-1-1,0 0 1,0-2 0,-1 0 0,22-23-1,-24 21 381,0 1 1,39-26-1,-32 25-469,28-25 0,-30 21-90,-4 5 0,-1-1 0,0-1 0,20-28 0,-11-8 0,-22 45 0,-1 0 0,1 0 0,1 1 0,-1 0 0,1 0 0,1 0 0,6-7 0,12-13 0,40-62 0,7-8 0,-54 78 0,-11 11 0,0 1 0,1 0 0,14-11 0,-17 14 0,-1 1 0,1 0 0,-1-1 0,0 0 0,-1 0 0,1 0 0,-1 0 0,0 0 0,0 0 0,0-1 0,-1 1 0,0-1 0,0 1 0,0-11 0,2 0 0,-3 15 0,0 1 0,0-1 0,0 0 0,0 0 0,0 0 0,0 0 0,0 1 0,0-1 0,0 0 0,0 0 0,-1 0 0,1 1 0,0-1 0,0 0 0,-1 0 0,1 0 0,0 1 0,-1-1 0,1 0 0,-1 1 0,1-1 0,-1 0 0,0 1 0,1-1 0,-1 1 0,1-1 0,-1 1 0,0-1 0,0 1 0,1-1 0,-1 1 0,0 0 0,0-1 0,1 1 0,-1 0 0,0 0 0,0 0 0,0 0 0,0-1 0,1 1 0,-1 0 0,0 0 0,0 0 0,0 1 0,-1-1 0,-48 9 0,37-6 0,-25 6 0,22-5 0,-1-1 0,1 0 0,-19 0 0,6 0 0,1 0 0,-52 14 0,-2 1 0,-2-1 0,54-10 0,1-2 0,-1 0 0,-35 0 0,6-6 0,27 0 0,1 1 0,0 1 0,-62 11 0,87-10-120,-11 2 373,17-2-568,11-1-868</inkml:trace>
+  <inkml:trace contextRef="#ctx0" brushRef="#br0">1 1 24575,'33'1'0,"-1"2"0,36 8 0,-39-6 0,-22-3 0,1 1 0,0 1 0,-1-1 0,0 0 0,-1 1 0,1 0 0,-1 1 0,0-1 0,0 1 0,7 7 0,-4-4 0,-1 0 0,2-1 0,17 10 0,71 34 0,-57-26 0,1-4 0,79 29 0,-87-38 0,0 1 0,35 22 0,-40-20 0,-1 0 0,2-3 0,37 12 0,-8-5 0,-1 2 0,65 33 0,-2 0 0,-103-48 0,2-1 0,0 0 0,32 4 0,-27-6 0,37 10 0,62 35 0,-18-5 0,-72-31 0,38 22 0,-45-20 0,0-2 0,49 16 0,63 19 0,-95-28 0,74 18 0,-87-28-198,0 1 1,0 2-1,45 25 0,12 5 143,45 15-14,172 65-914,-236-99 771,89 26 902,22 3-1450,21 6 1332,43-13-1361,-154-27 789,110 6 0,-11-2 0,-16-8 0,-23-4 0,-57-2 0,-46-5 0,63 14 0,165 28-1272,-8 6 1272,256 43-1608,-325-61 1608,98 10 0,76-3 0,-273-21 0,-15-3 0,116 8 0,-56-15 0,54 2 0,172 21 0,-227-15 0,563 48 0,-547-52 0,75 9 0,45-6 264,-78-8 58,413 2-1179,-375-12 605,610 2 252,-648 11 0,-2-1 0,-23-8 0,291-5 0,-222-17-217,104-25 217,-139 13 0,-12-8 0,-61 11 0,-83 15 0,71-8 0,-54 12 212,71-21-1,17-3-1097,-65 18 733,124-15 547,-158 23-394,69-15 0,30-6 0,-94 19 0,-2-2 0,2-4 0,101-39 0,-21 5 172,24-9 523,-29 11 571,-7 3-518,130-60-499,-190 68-249,-45 23 0,45-18 0,-2 5 0,124-72 0,-72 35 0,-102 53 179,2-1 0,-3-1-1,0 0 1,1-3 0,-2 1 0,23-24-1,-25 22 381,1 1 1,39-27-1,-33 26-469,29-26 0,-30 21-90,-5 6 0,-1-1 0,1-2 0,19-28 0,-10-8 0,-23 46 0,-1 0 0,1 0 0,1 1 0,-1 0 0,1-1 0,1 1 0,7-7 0,11-14 0,41-62 0,8-9 0,-56 79 0,-11 12 0,0 1 0,1 0 0,15-12 0,-18 15 0,-1 1 0,1 0 0,-1-1 0,0 0 0,-1 0 0,1 0 0,-1 0 0,0 0 0,0 0 0,0-2 0,-1 2 0,0-1 0,1 1 0,-1-11 0,2-1 0,-3 16 0,0 1 0,0-1 0,0 0 0,0 0 0,0 0 0,0 0 0,0 1 0,0-1 0,0 0 0,0 0 0,-1 0 0,1 1 0,0-1 0,0 0 0,-1 0 0,1 0 0,0 1 0,-1-1 0,1 0 0,-1 1 0,1-1 0,-2 0 0,1 1 0,1-1 0,-1 1 0,1-1 0,-1 1 0,0-1 0,0 1 0,1-1 0,-1 1 0,0 0 0,0-1 0,1 1 0,-1 0 0,0 0 0,0 0 0,0 0 0,0-1 0,1 1 0,-1 0 0,0 0 0,0 0 0,0 1 0,-1-1 0,-49 9 0,38-6 0,-26 6 0,23-4 0,-1-2 0,0 0 0,-18 0 0,5 0 0,1 0 0,-52 14 0,-3 2 0,-1-2 0,54-10 0,1-2 0,0 0 0,-36 0 0,5-6 0,29 0 0,0 1 0,1 1 0,-64 11 0,89-9-120,-12 1 373,18-2-568,12-1-868</inkml:trace>
 </inkml:ink>
 </file>
 
@@ -842,7 +842,7 @@
       <inkml:brushProperty name="color" value="#FF0066"/>
     </inkml:brush>
   </inkml:definitions>
-  <inkml:trace contextRef="#ctx0" brushRef="#br0">1 1 24575,'2'0'0,"1"0"0,0 1 0,-1 0 0,1-1 0,-1 1 0,1 0 0,-1 0 0,1 1 0,-1-1 0,0 0 0,0 1 0,0 0 0,1-1 0,2 4 0,30 36 0,-14-17 0,-14-14 0,0-1 0,0 1 0,-1 1 0,0-1 0,-1 1 0,0 0 0,7 22 0,-8-19 0,1-1 0,0 0 0,1-1 0,1 1 0,11 16 0,5 2 0,-17-21 0,1 0 0,0-1 0,1 1 0,0-2 0,1 1 0,14 11 0,-19-17 0,0 0 0,0 0 0,0 1 0,-1 0 0,0 0 0,1 0 0,-2 0 0,1 0 0,0 0 0,-1 1 0,4 9 0,8 13 0,24 22-1365</inkml:trace>
+  <inkml:trace contextRef="#ctx0" brushRef="#br0">1 1 24575,'2'0'0,"1"0"0,0 1 0,-1 0 0,1-1 0,-1 1 0,1 0 0,-1 0 0,1 1 0,-1-1 0,1 0 0,-1 1 0,0 0 0,1-1 0,2 4 0,30 37 0,-13-17 0,-15-15 0,0-1 0,0 1 0,-1 1 0,0 0 0,0 0 0,-1 0 0,7 23 0,-8-20 0,1-1 0,0 0 0,1 0 0,1 0 0,12 17 0,4 1 0,-17-21 0,1 1 0,1-2 0,0 1 0,0-2 0,1 1 0,15 12 0,-20-18 0,0 0 0,0 0 0,0 1 0,-1 0 0,0 0 0,1 0 0,-2 0 0,1 0 0,0 0 0,-1 1 0,4 10 0,9 12 0,23 23-1365</inkml:trace>
 </inkml:ink>
 </file>
 
@@ -1348,7 +1348,7 @@
           <a:p>
             <a:fld id="{B9658D5F-65FB-4E17-9D5B-8CF1DE5A98DF}" type="datetimeFigureOut">
               <a:rPr lang="en-US" smtClean="0"/>
-              <a:t>9/13/2026</a:t>
+              <a:t>9/14/2026</a:t>
             </a:fld>
             <a:endParaRPr lang="en-US"/>
           </a:p>
@@ -4331,7 +4331,7 @@
           <a:p>
             <a:fld id="{4263717A-E3C1-4BED-ABE0-B7069385E023}" type="datetimeFigureOut">
               <a:rPr lang="en-US" smtClean="0"/>
-              <a:t>9/13/2026</a:t>
+              <a:t>9/14/2026</a:t>
             </a:fld>
             <a:endParaRPr lang="en-US"/>
           </a:p>
@@ -4504,7 +4504,7 @@
           <a:p>
             <a:fld id="{4263717A-E3C1-4BED-ABE0-B7069385E023}" type="datetimeFigureOut">
               <a:rPr lang="en-US" smtClean="0"/>
-              <a:t>9/13/2026</a:t>
+              <a:t>9/14/2026</a:t>
             </a:fld>
             <a:endParaRPr lang="en-US"/>
           </a:p>
@@ -4682,7 +4682,7 @@
           <a:p>
             <a:fld id="{4263717A-E3C1-4BED-ABE0-B7069385E023}" type="datetimeFigureOut">
               <a:rPr lang="en-US" smtClean="0"/>
-              <a:t>9/13/2026</a:t>
+              <a:t>9/14/2026</a:t>
             </a:fld>
             <a:endParaRPr lang="en-US"/>
           </a:p>
@@ -4850,7 +4850,7 @@
           <a:p>
             <a:fld id="{4263717A-E3C1-4BED-ABE0-B7069385E023}" type="datetimeFigureOut">
               <a:rPr lang="en-US" smtClean="0"/>
-              <a:t>9/13/2026</a:t>
+              <a:t>9/14/2026</a:t>
             </a:fld>
             <a:endParaRPr lang="en-US"/>
           </a:p>
@@ -5095,7 +5095,7 @@
           <a:p>
             <a:fld id="{4263717A-E3C1-4BED-ABE0-B7069385E023}" type="datetimeFigureOut">
               <a:rPr lang="en-US" smtClean="0"/>
-              <a:t>9/13/2026</a:t>
+              <a:t>9/14/2026</a:t>
             </a:fld>
             <a:endParaRPr lang="en-US"/>
           </a:p>
@@ -5324,7 +5324,7 @@
           <a:p>
             <a:fld id="{4263717A-E3C1-4BED-ABE0-B7069385E023}" type="datetimeFigureOut">
               <a:rPr lang="en-US" smtClean="0"/>
-              <a:t>9/13/2026</a:t>
+              <a:t>9/14/2026</a:t>
             </a:fld>
             <a:endParaRPr lang="en-US"/>
           </a:p>
@@ -5688,7 +5688,7 @@
           <a:p>
             <a:fld id="{4263717A-E3C1-4BED-ABE0-B7069385E023}" type="datetimeFigureOut">
               <a:rPr lang="en-US" smtClean="0"/>
-              <a:t>9/13/2026</a:t>
+              <a:t>9/14/2026</a:t>
             </a:fld>
             <a:endParaRPr lang="en-US"/>
           </a:p>
@@ -5805,7 +5805,7 @@
           <a:p>
             <a:fld id="{4263717A-E3C1-4BED-ABE0-B7069385E023}" type="datetimeFigureOut">
               <a:rPr lang="en-US" smtClean="0"/>
-              <a:t>9/13/2026</a:t>
+              <a:t>9/14/2026</a:t>
             </a:fld>
             <a:endParaRPr lang="en-US"/>
           </a:p>
@@ -5900,7 +5900,7 @@
           <a:p>
             <a:fld id="{4263717A-E3C1-4BED-ABE0-B7069385E023}" type="datetimeFigureOut">
               <a:rPr lang="en-US" smtClean="0"/>
-              <a:t>9/13/2026</a:t>
+              <a:t>9/14/2026</a:t>
             </a:fld>
             <a:endParaRPr lang="en-US"/>
           </a:p>
@@ -6175,7 +6175,7 @@
           <a:p>
             <a:fld id="{4263717A-E3C1-4BED-ABE0-B7069385E023}" type="datetimeFigureOut">
               <a:rPr lang="en-US" smtClean="0"/>
-              <a:t>9/13/2026</a:t>
+              <a:t>9/14/2026</a:t>
             </a:fld>
             <a:endParaRPr lang="en-US"/>
           </a:p>
@@ -6427,7 +6427,7 @@
           <a:p>
             <a:fld id="{4263717A-E3C1-4BED-ABE0-B7069385E023}" type="datetimeFigureOut">
               <a:rPr lang="en-US" smtClean="0"/>
-              <a:t>9/13/2026</a:t>
+              <a:t>9/14/2026</a:t>
             </a:fld>
             <a:endParaRPr lang="en-US"/>
           </a:p>
@@ -6638,7 +6638,7 @@
           <a:p>
             <a:fld id="{4263717A-E3C1-4BED-ABE0-B7069385E023}" type="datetimeFigureOut">
               <a:rPr lang="en-US" smtClean="0"/>
-              <a:t>9/13/2026</a:t>
+              <a:t>9/14/2026</a:t>
             </a:fld>
             <a:endParaRPr lang="en-US"/>
           </a:p>
@@ -8359,6 +8359,7 @@
               <a:defRPr sz="3600" b="0"/>
             </a:pPr>
             <a:r>
+              <a:rPr dirty="0"/>
               <a:t>Decimal to Binary: Repeated Division</a:t>
             </a:r>
           </a:p>
@@ -10356,7 +10357,7 @@
         </p:nvSpPr>
         <p:spPr bwMode="auto">
           <a:xfrm>
-            <a:off x="6686982" y="740904"/>
+            <a:off x="7085993" y="751542"/>
             <a:ext cx="3867363" cy="523220"/>
           </a:xfrm>
           <a:prstGeom prst="rect">
@@ -16254,8 +16255,8 @@
         </p:nvGrpSpPr>
         <p:grpSpPr>
           <a:xfrm>
-            <a:off x="1063496" y="3413846"/>
-            <a:ext cx="7045560" cy="844560"/>
+            <a:off x="1395307" y="2805112"/>
+            <a:ext cx="7182730" cy="861003"/>
             <a:chOff x="1063496" y="3299546"/>
             <a:chExt cx="7045560" cy="844560"/>
           </a:xfrm>
@@ -22050,6 +22051,7 @@
               <a:defRPr sz="2500"/>
             </a:pPr>
             <a:r>
+              <a:rPr dirty="0"/>
               <a:t>Cocoa/Core Data time uses seconds since 2001-01-01 00:00:00 UTC.</a:t>
             </a:r>
           </a:p>
@@ -22061,6 +22063,7 @@
               <a:defRPr sz="2500"/>
             </a:pPr>
             <a:r>
+              <a:rPr dirty="0"/>
               <a:t>Unix time uses seconds since 1970-01-01 00:00:00 UTC.</a:t>
             </a:r>
           </a:p>
@@ -22072,6 +22075,7 @@
               <a:defRPr sz="2500"/>
             </a:pPr>
             <a:r>
+              <a:rPr dirty="0"/>
               <a:t>The offset is 978,307,200 seconds.</a:t>
             </a:r>
           </a:p>
@@ -22083,6 +22087,7 @@
               <a:defRPr sz="2500"/>
             </a:pPr>
             <a:r>
+              <a:rPr dirty="0"/>
               <a:t>Convert by adding or subtracting this offset before interpreting the timestamp.</a:t>
             </a:r>
           </a:p>
@@ -28772,8 +28777,8 @@
           </a:fontRef>
         </p:style>
       </p:cxnSp>
-      <mc:AlternateContent xmlns:mc="http://schemas.openxmlformats.org/markup-compatibility/2006">
-        <mc:Choice xmlns:p14="http://schemas.microsoft.com/office/powerpoint/2010/main" Requires="p14">
+      <mc:AlternateContent xmlns:mc="http://schemas.openxmlformats.org/markup-compatibility/2006" xmlns:p14="http://schemas.microsoft.com/office/powerpoint/2010/main">
+        <mc:Choice Requires="p14">
           <p:contentPart p14:bwMode="auto" r:id="rId5">
             <p14:nvContentPartPr>
               <p14:cNvPr id="25" name="Ink 24">
@@ -28792,7 +28797,7 @@
             </p14:xfrm>
           </p:contentPart>
         </mc:Choice>
-        <mc:Fallback>
+        <mc:Fallback xmlns="">
           <p:pic>
             <p:nvPicPr>
               <p:cNvPr id="25" name="Ink 24">
@@ -28823,8 +28828,8 @@
           </p:pic>
         </mc:Fallback>
       </mc:AlternateContent>
-      <mc:AlternateContent xmlns:mc="http://schemas.openxmlformats.org/markup-compatibility/2006">
-        <mc:Choice xmlns:p14="http://schemas.microsoft.com/office/powerpoint/2010/main" Requires="p14">
+      <mc:AlternateContent xmlns:mc="http://schemas.openxmlformats.org/markup-compatibility/2006" xmlns:p14="http://schemas.microsoft.com/office/powerpoint/2010/main">
+        <mc:Choice Requires="p14">
           <p:contentPart p14:bwMode="auto" r:id="rId7">
             <p14:nvContentPartPr>
               <p14:cNvPr id="26" name="Ink 25">
@@ -28843,7 +28848,7 @@
             </p14:xfrm>
           </p:contentPart>
         </mc:Choice>
-        <mc:Fallback>
+        <mc:Fallback xmlns="">
           <p:pic>
             <p:nvPicPr>
               <p:cNvPr id="26" name="Ink 25">

</xml_diff>